<commit_message>
Refactor code structure and remove redundant sections for improved readability
</commit_message>
<xml_diff>
--- a/diagram/AI智能客服-AF06-万佳恒.pptx
+++ b/diagram/AI智能客服-AF06-万佳恒.pptx
@@ -12,7 +12,6 @@
     <p:sldId xmlns:r="http://schemas.openxmlformats.org/officeDocument/2006/relationships" id="257" r:id="Rfdcc4a8e289345cf"/>
     <p:sldId xmlns:r="http://schemas.openxmlformats.org/officeDocument/2006/relationships" id="258" r:id="R3e9077ece65d4a66"/>
     <p:sldId xmlns:r="http://schemas.openxmlformats.org/officeDocument/2006/relationships" id="259" r:id="Rb1e46912e4cf477b"/>
-    <p:sldId xmlns:ns1="http://schemas.openxmlformats.org/officeDocument/2006/relationships" id="261" ns1:id="RParentChildIngestion"/>
     <p:sldId xmlns:r="http://schemas.openxmlformats.org/officeDocument/2006/relationships" id="260" r:id="R4b7e67e6407e4640"/>
   </p:sldIdLst>
   <p:sldSz cx="12192000" cy="6858000"/>
@@ -4247,7 +4246,7 @@
       </p:sp>
       <p:sp>
         <p:nvSpPr>
-          <p:cNvPr id="4" name="1 / 6">
+          <p:cNvPr id="4" name="1 / 5">
             <a:extLst xmlns:a="http://schemas.openxmlformats.org/drawingml/2006/main">
               <a:ext uri="{FF2B5EF4-FFF2-40B4-BE49-F238E27FC236}">
                 <a16:creationId xmlns:a16="http://schemas.microsoft.com/office/drawing/2014/main" id="{F913592F-7DFC-4DFE-AF09-E51994296E81}"/>
@@ -4398,7 +4397,7 @@
                 <a:ea typeface="Heiti TC"/>
                 <a:cs typeface="Heiti TC"/>
               </a:rPr>
-              <a:t>1 / 6</a:t>
+              <a:t>1 / 5</a:t>
             </a:r>
           </a:p>
         </p:txBody>
@@ -7323,7 +7322,7 @@
       </p:sp>
       <p:sp>
         <p:nvSpPr>
-          <p:cNvPr id="4" name="2 / 6">
+          <p:cNvPr id="4" name="2 / 5">
             <a:extLst xmlns:a="http://schemas.openxmlformats.org/drawingml/2006/main">
               <a:ext uri="{FF2B5EF4-FFF2-40B4-BE49-F238E27FC236}">
                 <a16:creationId xmlns:a16="http://schemas.microsoft.com/office/drawing/2014/main" id="{2AAE846F-82CA-4221-A2CA-B1466EBEDA35}"/>
@@ -7474,7 +7473,7 @@
                 <a:ea typeface="Heiti TC"/>
                 <a:cs typeface="Heiti TC"/>
               </a:rPr>
-              <a:t>2 / 6</a:t>
+              <a:t>2 / 5</a:t>
             </a:r>
           </a:p>
         </p:txBody>
@@ -10316,7 +10315,7 @@
       </p:sp>
       <p:sp>
         <p:nvSpPr>
-          <p:cNvPr id="4" name="3 / 6">
+          <p:cNvPr id="4" name="3 / 5">
             <a:extLst xmlns:a="http://schemas.openxmlformats.org/drawingml/2006/main">
               <a:ext uri="{FF2B5EF4-FFF2-40B4-BE49-F238E27FC236}">
                 <a16:creationId xmlns:a16="http://schemas.microsoft.com/office/drawing/2014/main" id="{B2E79699-A706-4026-A09A-A27AA0A87F3F}"/>
@@ -10467,7 +10466,7 @@
                 <a:ea typeface="Heiti TC"/>
                 <a:cs typeface="Heiti TC"/>
               </a:rPr>
-              <a:t>3 / 6</a:t>
+              <a:t>3 / 5</a:t>
             </a:r>
           </a:p>
         </p:txBody>
@@ -14484,7 +14483,7 @@
       </p:sp>
       <p:sp>
         <p:nvSpPr>
-          <p:cNvPr id="4" name="4 / 6">
+          <p:cNvPr id="4" name="4 / 5">
             <a:extLst xmlns:a="http://schemas.openxmlformats.org/drawingml/2006/main">
               <a:ext uri="{FF2B5EF4-FFF2-40B4-BE49-F238E27FC236}">
                 <a16:creationId xmlns:a16="http://schemas.microsoft.com/office/drawing/2014/main" id="{EDEB8FFF-7032-4A06-BC61-339C4F23DB09}"/>
@@ -14635,7 +14634,7 @@
                 <a:ea typeface="Heiti TC"/>
                 <a:cs typeface="Heiti TC"/>
               </a:rPr>
-              <a:t>4 / 6</a:t>
+              <a:t>4 / 5</a:t>
             </a:r>
           </a:p>
         </p:txBody>
@@ -19375,7 +19374,7 @@
       </p:sp>
       <p:sp>
         <p:nvSpPr>
-          <p:cNvPr id="4" name="6 / 6">
+          <p:cNvPr id="4" name="5 / 5">
             <a:extLst xmlns:a="http://schemas.openxmlformats.org/drawingml/2006/main">
               <a:ext uri="{FF2B5EF4-FFF2-40B4-BE49-F238E27FC236}">
                 <a16:creationId xmlns:a16="http://schemas.microsoft.com/office/drawing/2014/main" id="{B9A57BD1-16F4-4A90-B85B-78B3CE2FA0A6}"/>
@@ -19526,7 +19525,7 @@
                 <a:ea typeface="Heiti TC"/>
                 <a:cs typeface="Heiti TC"/>
               </a:rPr>
-              <a:t>6 / 6</a:t>
+              <a:t>5 / 5</a:t>
             </a:r>
           </a:p>
         </p:txBody>
@@ -22772,3469 +22771,6 @@
     <p:extLst>
       <p:ext uri="{BB962C8B-B14F-4D97-AF65-F5344CB8AC3E}">
         <p14:creationId xmlns:p14="http://schemas.microsoft.com/office/powerpoint/2010/main" val="1176423365"/>
-      </p:ext>
-    </p:extLst>
-  </p:cSld>
-</p:sld>
-</file>
-
-<file path=ppt/slides/slide6.xml><?xml version="1.0" encoding="utf-8"?>
-<p:sld xmlns:p="http://schemas.openxmlformats.org/presentationml/2006/main">
-  <p:cSld>
-    <p:bg>
-      <p:bgPr>
-        <a:solidFill xmlns:a="http://schemas.openxmlformats.org/drawingml/2006/main">
-          <a:srgbClr val="F7F9FC"/>
-        </a:solidFill>
-      </p:bgPr>
-    </p:bg>
-    <p:spTree>
-      <p:nvGrpSpPr>
-        <p:cNvPr id="1" name=""/>
-        <p:cNvGrpSpPr/>
-        <p:nvPr/>
-      </p:nvGrpSpPr>
-      <p:grpSpPr>
-        <a:xfrm xmlns:a="http://schemas.openxmlformats.org/drawingml/2006/main"/>
-      </p:grpSpPr>
-      <p:sp>
-        <p:nvSpPr>
-          <p:cNvPr id="26" name="项目亮点">
-            <a:extLst xmlns:a="http://schemas.openxmlformats.org/drawingml/2006/main">
-              <a:ext uri="{FF2B5EF4-FFF2-40B4-BE49-F238E27FC236}">
-                <a16:creationId xmlns:a16="http://schemas.microsoft.com/office/drawing/2014/main" id="{68C9D8DC-3B22-4B33-8E61-C9BEE2B9A8B0}"/>
-              </a:ext>
-            </a:extLst>
-          </p:cNvPr>
-          <p:cNvSpPr>
-            <a:spLocks xmlns:a="http://schemas.openxmlformats.org/drawingml/2006/main" noGrp="1"/>
-          </p:cNvSpPr>
-          <p:nvPr/>
-        </p:nvSpPr>
-        <p:spPr>
-          <a:xfrm xmlns:a="http://schemas.openxmlformats.org/drawingml/2006/main">
-            <a:off x="523875" y="333375"/>
-            <a:ext cx="10763250" cy="552450"/>
-          </a:xfrm>
-          <a:prstGeom xmlns:a="http://schemas.openxmlformats.org/drawingml/2006/main" prst="rect">
-            <a:avLst/>
-          </a:prstGeom>
-          <a:noFill xmlns:a="http://schemas.openxmlformats.org/drawingml/2006/main"/>
-          <a:ln xmlns:a="http://schemas.openxmlformats.org/drawingml/2006/main" w="0">
-            <a:noFill/>
-          </a:ln>
-        </p:spPr>
-        <p:txBody>
-          <a:bodyPr xmlns:a="http://schemas.openxmlformats.org/drawingml/2006/main" wrap="square" lIns="0" tIns="0" rIns="0" bIns="0" anchor="ctr">
-            <a:noAutofit/>
-          </a:bodyPr>
-          <a:lstStyle xmlns:a="http://schemas.openxmlformats.org/drawingml/2006/main">
-            <a:defPPr algn="l">
-              <a:defRPr sz="3150" b="1">
-                <a:solidFill>
-                  <a:srgbClr val="102B40"/>
-                </a:solidFill>
-                <a:latin typeface="Heiti TC"/>
-                <a:ea typeface="Heiti TC"/>
-                <a:cs typeface="Heiti TC"/>
-              </a:defRPr>
-            </a:defPPr>
-            <a:lvl1pPr algn="l">
-              <a:defRPr sz="3150" b="1">
-                <a:solidFill>
-                  <a:srgbClr val="102B40"/>
-                </a:solidFill>
-                <a:latin typeface="Heiti TC"/>
-                <a:ea typeface="Heiti TC"/>
-                <a:cs typeface="Heiti TC"/>
-              </a:defRPr>
-            </a:lvl1pPr>
-            <a:lvl2pPr algn="l">
-              <a:defRPr sz="3150" b="1">
-                <a:solidFill>
-                  <a:srgbClr val="102B40"/>
-                </a:solidFill>
-                <a:latin typeface="Heiti TC"/>
-                <a:ea typeface="Heiti TC"/>
-                <a:cs typeface="Heiti TC"/>
-              </a:defRPr>
-            </a:lvl2pPr>
-            <a:lvl3pPr algn="l">
-              <a:defRPr sz="3150" b="1">
-                <a:solidFill>
-                  <a:srgbClr val="102B40"/>
-                </a:solidFill>
-                <a:latin typeface="Heiti TC"/>
-                <a:ea typeface="Heiti TC"/>
-                <a:cs typeface="Heiti TC"/>
-              </a:defRPr>
-            </a:lvl3pPr>
-            <a:lvl4pPr algn="l">
-              <a:defRPr sz="3150" b="1">
-                <a:solidFill>
-                  <a:srgbClr val="102B40"/>
-                </a:solidFill>
-                <a:latin typeface="Heiti TC"/>
-                <a:ea typeface="Heiti TC"/>
-                <a:cs typeface="Heiti TC"/>
-              </a:defRPr>
-            </a:lvl4pPr>
-            <a:lvl5pPr algn="l">
-              <a:defRPr sz="3150" b="1">
-                <a:solidFill>
-                  <a:srgbClr val="102B40"/>
-                </a:solidFill>
-                <a:latin typeface="Heiti TC"/>
-                <a:ea typeface="Heiti TC"/>
-                <a:cs typeface="Heiti TC"/>
-              </a:defRPr>
-            </a:lvl5pPr>
-            <a:lvl6pPr algn="l">
-              <a:defRPr sz="3150" b="1">
-                <a:solidFill>
-                  <a:srgbClr val="102B40"/>
-                </a:solidFill>
-                <a:latin typeface="Heiti TC"/>
-                <a:ea typeface="Heiti TC"/>
-                <a:cs typeface="Heiti TC"/>
-              </a:defRPr>
-            </a:lvl6pPr>
-            <a:lvl7pPr algn="l">
-              <a:defRPr sz="3150" b="1">
-                <a:solidFill>
-                  <a:srgbClr val="102B40"/>
-                </a:solidFill>
-                <a:latin typeface="Heiti TC"/>
-                <a:ea typeface="Heiti TC"/>
-                <a:cs typeface="Heiti TC"/>
-              </a:defRPr>
-            </a:lvl7pPr>
-            <a:lvl8pPr algn="l">
-              <a:defRPr sz="3150" b="1">
-                <a:solidFill>
-                  <a:srgbClr val="102B40"/>
-                </a:solidFill>
-                <a:latin typeface="Heiti TC"/>
-                <a:ea typeface="Heiti TC"/>
-                <a:cs typeface="Heiti TC"/>
-              </a:defRPr>
-            </a:lvl8pPr>
-            <a:lvl9pPr algn="l">
-              <a:defRPr sz="3150" b="1">
-                <a:solidFill>
-                  <a:srgbClr val="102B40"/>
-                </a:solidFill>
-                <a:latin typeface="Heiti TC"/>
-                <a:ea typeface="Heiti TC"/>
-                <a:cs typeface="Heiti TC"/>
-              </a:defRPr>
-            </a:lvl9pPr>
-          </a:lstStyle>
-          <a:p xmlns:a="http://schemas.openxmlformats.org/drawingml/2006/main">
-            <a:pPr algn="l">
-              <a:defRPr sz="3150" b="1">
-                <a:solidFill>
-                  <a:srgbClr val="102B40"/>
-                </a:solidFill>
-                <a:latin typeface="Heiti TC"/>
-                <a:ea typeface="Heiti TC"/>
-                <a:cs typeface="Heiti TC"/>
-              </a:defRPr>
-            </a:pPr>
-            <a:r>
-              <a:rPr sz="3150" b="1">
-                <a:solidFill>
-                  <a:srgbClr val="102B40"/>
-                </a:solidFill>
-                <a:latin typeface="Heiti TC"/>
-                <a:ea typeface="Heiti TC"/>
-                <a:cs typeface="Heiti TC"/>
-              </a:rPr>
-              <a:t>Markdown 父子分块与入库</a:t>
-            </a:r>
-          </a:p>
-        </p:txBody>
-      </p:sp>
-      <p:sp>
-        <p:nvSpPr>
-          <p:cNvPr id="2" name="围绕实际问答与办理过程，保持流程可追踪、证据有来源、写操作有确认">
-            <a:extLst xmlns:a="http://schemas.openxmlformats.org/drawingml/2006/main">
-              <a:ext uri="{FF2B5EF4-FFF2-40B4-BE49-F238E27FC236}">
-                <a16:creationId xmlns:a16="http://schemas.microsoft.com/office/drawing/2014/main" id="{7A26105C-6981-4B20-BD97-FC883042E4F4}"/>
-              </a:ext>
-            </a:extLst>
-          </p:cNvPr>
-          <p:cNvSpPr>
-            <a:spLocks xmlns:a="http://schemas.openxmlformats.org/drawingml/2006/main" noGrp="1"/>
-          </p:cNvSpPr>
-          <p:nvPr/>
-        </p:nvSpPr>
-        <p:spPr>
-          <a:xfrm xmlns:a="http://schemas.openxmlformats.org/drawingml/2006/main">
-            <a:off x="542925" y="942975"/>
-            <a:ext cx="10953750" cy="352425"/>
-          </a:xfrm>
-          <a:prstGeom xmlns:a="http://schemas.openxmlformats.org/drawingml/2006/main" prst="rect">
-            <a:avLst/>
-          </a:prstGeom>
-          <a:noFill xmlns:a="http://schemas.openxmlformats.org/drawingml/2006/main"/>
-          <a:ln xmlns:a="http://schemas.openxmlformats.org/drawingml/2006/main" w="0">
-            <a:noFill/>
-          </a:ln>
-        </p:spPr>
-        <p:txBody>
-          <a:bodyPr xmlns:a="http://schemas.openxmlformats.org/drawingml/2006/main" wrap="square" lIns="0" tIns="0" rIns="0" bIns="0" anchor="ctr">
-            <a:noAutofit/>
-          </a:bodyPr>
-          <a:lstStyle xmlns:a="http://schemas.openxmlformats.org/drawingml/2006/main">
-            <a:defPPr algn="l">
-              <a:defRPr sz="1725" b="0">
-                <a:solidFill>
-                  <a:srgbClr val="536A79"/>
-                </a:solidFill>
-                <a:latin typeface="Heiti TC"/>
-                <a:ea typeface="Heiti TC"/>
-                <a:cs typeface="Heiti TC"/>
-              </a:defRPr>
-            </a:defPPr>
-            <a:lvl1pPr algn="l">
-              <a:defRPr sz="1725" b="0">
-                <a:solidFill>
-                  <a:srgbClr val="536A79"/>
-                </a:solidFill>
-                <a:latin typeface="Heiti TC"/>
-                <a:ea typeface="Heiti TC"/>
-                <a:cs typeface="Heiti TC"/>
-              </a:defRPr>
-            </a:lvl1pPr>
-            <a:lvl2pPr algn="l">
-              <a:defRPr sz="1725" b="0">
-                <a:solidFill>
-                  <a:srgbClr val="536A79"/>
-                </a:solidFill>
-                <a:latin typeface="Heiti TC"/>
-                <a:ea typeface="Heiti TC"/>
-                <a:cs typeface="Heiti TC"/>
-              </a:defRPr>
-            </a:lvl2pPr>
-            <a:lvl3pPr algn="l">
-              <a:defRPr sz="1725" b="0">
-                <a:solidFill>
-                  <a:srgbClr val="536A79"/>
-                </a:solidFill>
-                <a:latin typeface="Heiti TC"/>
-                <a:ea typeface="Heiti TC"/>
-                <a:cs typeface="Heiti TC"/>
-              </a:defRPr>
-            </a:lvl3pPr>
-            <a:lvl4pPr algn="l">
-              <a:defRPr sz="1725" b="0">
-                <a:solidFill>
-                  <a:srgbClr val="536A79"/>
-                </a:solidFill>
-                <a:latin typeface="Heiti TC"/>
-                <a:ea typeface="Heiti TC"/>
-                <a:cs typeface="Heiti TC"/>
-              </a:defRPr>
-            </a:lvl4pPr>
-            <a:lvl5pPr algn="l">
-              <a:defRPr sz="1725" b="0">
-                <a:solidFill>
-                  <a:srgbClr val="536A79"/>
-                </a:solidFill>
-                <a:latin typeface="Heiti TC"/>
-                <a:ea typeface="Heiti TC"/>
-                <a:cs typeface="Heiti TC"/>
-              </a:defRPr>
-            </a:lvl5pPr>
-            <a:lvl6pPr algn="l">
-              <a:defRPr sz="1725" b="0">
-                <a:solidFill>
-                  <a:srgbClr val="536A79"/>
-                </a:solidFill>
-                <a:latin typeface="Heiti TC"/>
-                <a:ea typeface="Heiti TC"/>
-                <a:cs typeface="Heiti TC"/>
-              </a:defRPr>
-            </a:lvl6pPr>
-            <a:lvl7pPr algn="l">
-              <a:defRPr sz="1725" b="0">
-                <a:solidFill>
-                  <a:srgbClr val="536A79"/>
-                </a:solidFill>
-                <a:latin typeface="Heiti TC"/>
-                <a:ea typeface="Heiti TC"/>
-                <a:cs typeface="Heiti TC"/>
-              </a:defRPr>
-            </a:lvl7pPr>
-            <a:lvl8pPr algn="l">
-              <a:defRPr sz="1725" b="0">
-                <a:solidFill>
-                  <a:srgbClr val="536A79"/>
-                </a:solidFill>
-                <a:latin typeface="Heiti TC"/>
-                <a:ea typeface="Heiti TC"/>
-                <a:cs typeface="Heiti TC"/>
-              </a:defRPr>
-            </a:lvl8pPr>
-            <a:lvl9pPr algn="l">
-              <a:defRPr sz="1725" b="0">
-                <a:solidFill>
-                  <a:srgbClr val="536A79"/>
-                </a:solidFill>
-                <a:latin typeface="Heiti TC"/>
-                <a:ea typeface="Heiti TC"/>
-                <a:cs typeface="Heiti TC"/>
-              </a:defRPr>
-            </a:lvl9pPr>
-          </a:lstStyle>
-          <a:p xmlns:a="http://schemas.openxmlformats.org/drawingml/2006/main">
-            <a:pPr algn="l">
-              <a:defRPr sz="1725" b="0">
-                <a:solidFill>
-                  <a:srgbClr val="536A79"/>
-                </a:solidFill>
-                <a:latin typeface="Heiti TC"/>
-                <a:ea typeface="Heiti TC"/>
-                <a:cs typeface="Heiti TC"/>
-              </a:defRPr>
-            </a:pPr>
-            <a:r>
-              <a:rPr sz="1725" b="0">
-                <a:solidFill>
-                  <a:srgbClr val="536A79"/>
-                </a:solidFill>
-                <a:latin typeface="Heiti TC"/>
-                <a:ea typeface="Heiti TC"/>
-                <a:cs typeface="Heiti TC"/>
-              </a:rPr>
-              <a:t>按主题保留完整上下文，在父块内部切分子块，分别保存正文与检索索引</a:t>
-            </a:r>
-          </a:p>
-        </p:txBody>
-      </p:sp>
-      <p:sp>
-        <p:nvSpPr>
-          <p:cNvPr id="3" name="AI智能客服  /  万佳恒">
-            <a:extLst xmlns:a="http://schemas.openxmlformats.org/drawingml/2006/main">
-              <a:ext uri="{FF2B5EF4-FFF2-40B4-BE49-F238E27FC236}">
-                <a16:creationId xmlns:a16="http://schemas.microsoft.com/office/drawing/2014/main" id="{D714EB68-E240-42A3-8BEE-D1123CF3572E}"/>
-              </a:ext>
-            </a:extLst>
-          </p:cNvPr>
-          <p:cNvSpPr>
-            <a:spLocks xmlns:a="http://schemas.openxmlformats.org/drawingml/2006/main" noGrp="1"/>
-          </p:cNvSpPr>
-          <p:nvPr/>
-        </p:nvSpPr>
-        <p:spPr>
-          <a:xfrm xmlns:a="http://schemas.openxmlformats.org/drawingml/2006/main">
-            <a:off x="523875" y="6496050"/>
-            <a:ext cx="7143750" cy="209550"/>
-          </a:xfrm>
-          <a:prstGeom xmlns:a="http://schemas.openxmlformats.org/drawingml/2006/main" prst="rect">
-            <a:avLst/>
-          </a:prstGeom>
-          <a:noFill xmlns:a="http://schemas.openxmlformats.org/drawingml/2006/main"/>
-          <a:ln xmlns:a="http://schemas.openxmlformats.org/drawingml/2006/main" w="0">
-            <a:noFill/>
-          </a:ln>
-        </p:spPr>
-        <p:txBody>
-          <a:bodyPr xmlns:a="http://schemas.openxmlformats.org/drawingml/2006/main" wrap="square" lIns="0" tIns="0" rIns="0" bIns="0" anchor="ctr">
-            <a:noAutofit/>
-          </a:bodyPr>
-          <a:lstStyle xmlns:a="http://schemas.openxmlformats.org/drawingml/2006/main">
-            <a:defPPr algn="l">
-              <a:defRPr sz="1275" b="0">
-                <a:solidFill>
-                  <a:srgbClr val="536A79"/>
-                </a:solidFill>
-                <a:latin typeface="Heiti TC"/>
-                <a:ea typeface="Heiti TC"/>
-                <a:cs typeface="Heiti TC"/>
-              </a:defRPr>
-            </a:defPPr>
-            <a:lvl1pPr algn="l">
-              <a:defRPr sz="1275" b="0">
-                <a:solidFill>
-                  <a:srgbClr val="536A79"/>
-                </a:solidFill>
-                <a:latin typeface="Heiti TC"/>
-                <a:ea typeface="Heiti TC"/>
-                <a:cs typeface="Heiti TC"/>
-              </a:defRPr>
-            </a:lvl1pPr>
-            <a:lvl2pPr algn="l">
-              <a:defRPr sz="1275" b="0">
-                <a:solidFill>
-                  <a:srgbClr val="536A79"/>
-                </a:solidFill>
-                <a:latin typeface="Heiti TC"/>
-                <a:ea typeface="Heiti TC"/>
-                <a:cs typeface="Heiti TC"/>
-              </a:defRPr>
-            </a:lvl2pPr>
-            <a:lvl3pPr algn="l">
-              <a:defRPr sz="1275" b="0">
-                <a:solidFill>
-                  <a:srgbClr val="536A79"/>
-                </a:solidFill>
-                <a:latin typeface="Heiti TC"/>
-                <a:ea typeface="Heiti TC"/>
-                <a:cs typeface="Heiti TC"/>
-              </a:defRPr>
-            </a:lvl3pPr>
-            <a:lvl4pPr algn="l">
-              <a:defRPr sz="1275" b="0">
-                <a:solidFill>
-                  <a:srgbClr val="536A79"/>
-                </a:solidFill>
-                <a:latin typeface="Heiti TC"/>
-                <a:ea typeface="Heiti TC"/>
-                <a:cs typeface="Heiti TC"/>
-              </a:defRPr>
-            </a:lvl4pPr>
-            <a:lvl5pPr algn="l">
-              <a:defRPr sz="1275" b="0">
-                <a:solidFill>
-                  <a:srgbClr val="536A79"/>
-                </a:solidFill>
-                <a:latin typeface="Heiti TC"/>
-                <a:ea typeface="Heiti TC"/>
-                <a:cs typeface="Heiti TC"/>
-              </a:defRPr>
-            </a:lvl5pPr>
-            <a:lvl6pPr algn="l">
-              <a:defRPr sz="1275" b="0">
-                <a:solidFill>
-                  <a:srgbClr val="536A79"/>
-                </a:solidFill>
-                <a:latin typeface="Heiti TC"/>
-                <a:ea typeface="Heiti TC"/>
-                <a:cs typeface="Heiti TC"/>
-              </a:defRPr>
-            </a:lvl6pPr>
-            <a:lvl7pPr algn="l">
-              <a:defRPr sz="1275" b="0">
-                <a:solidFill>
-                  <a:srgbClr val="536A79"/>
-                </a:solidFill>
-                <a:latin typeface="Heiti TC"/>
-                <a:ea typeface="Heiti TC"/>
-                <a:cs typeface="Heiti TC"/>
-              </a:defRPr>
-            </a:lvl7pPr>
-            <a:lvl8pPr algn="l">
-              <a:defRPr sz="1275" b="0">
-                <a:solidFill>
-                  <a:srgbClr val="536A79"/>
-                </a:solidFill>
-                <a:latin typeface="Heiti TC"/>
-                <a:ea typeface="Heiti TC"/>
-                <a:cs typeface="Heiti TC"/>
-              </a:defRPr>
-            </a:lvl8pPr>
-            <a:lvl9pPr algn="l">
-              <a:defRPr sz="1275" b="0">
-                <a:solidFill>
-                  <a:srgbClr val="536A79"/>
-                </a:solidFill>
-                <a:latin typeface="Heiti TC"/>
-                <a:ea typeface="Heiti TC"/>
-                <a:cs typeface="Heiti TC"/>
-              </a:defRPr>
-            </a:lvl9pPr>
-          </a:lstStyle>
-          <a:p xmlns:a="http://schemas.openxmlformats.org/drawingml/2006/main">
-            <a:pPr algn="l">
-              <a:defRPr sz="1275" b="0">
-                <a:solidFill>
-                  <a:srgbClr val="536A79"/>
-                </a:solidFill>
-                <a:latin typeface="Heiti TC"/>
-                <a:ea typeface="Heiti TC"/>
-                <a:cs typeface="Heiti TC"/>
-              </a:defRPr>
-            </a:pPr>
-            <a:r>
-              <a:rPr sz="1275" b="0">
-                <a:solidFill>
-                  <a:srgbClr val="536A79"/>
-                </a:solidFill>
-                <a:latin typeface="Heiti TC"/>
-                <a:ea typeface="Heiti TC"/>
-                <a:cs typeface="Heiti TC"/>
-              </a:rPr>
-              <a:t>AI智能客服  /  万佳恒</a:t>
-            </a:r>
-          </a:p>
-        </p:txBody>
-      </p:sp>
-      <p:sp>
-        <p:nvSpPr>
-          <p:cNvPr id="4" name="3 / 5">
-            <a:extLst xmlns:a="http://schemas.openxmlformats.org/drawingml/2006/main">
-              <a:ext uri="{FF2B5EF4-FFF2-40B4-BE49-F238E27FC236}">
-                <a16:creationId xmlns:a16="http://schemas.microsoft.com/office/drawing/2014/main" id="{B2E79699-A706-4026-A09A-A27AA0A87F3F}"/>
-              </a:ext>
-            </a:extLst>
-          </p:cNvPr>
-          <p:cNvSpPr>
-            <a:spLocks xmlns:a="http://schemas.openxmlformats.org/drawingml/2006/main" noGrp="1"/>
-          </p:cNvSpPr>
-          <p:nvPr/>
-        </p:nvSpPr>
-        <p:spPr>
-          <a:xfrm xmlns:a="http://schemas.openxmlformats.org/drawingml/2006/main">
-            <a:off x="10763250" y="6496050"/>
-            <a:ext cx="904875" cy="209550"/>
-          </a:xfrm>
-          <a:prstGeom xmlns:a="http://schemas.openxmlformats.org/drawingml/2006/main" prst="rect">
-            <a:avLst/>
-          </a:prstGeom>
-          <a:noFill xmlns:a="http://schemas.openxmlformats.org/drawingml/2006/main"/>
-          <a:ln xmlns:a="http://schemas.openxmlformats.org/drawingml/2006/main" w="0">
-            <a:noFill/>
-          </a:ln>
-        </p:spPr>
-        <p:txBody>
-          <a:bodyPr xmlns:a="http://schemas.openxmlformats.org/drawingml/2006/main" wrap="square" lIns="0" tIns="0" rIns="0" bIns="0" anchor="ctr">
-            <a:noAutofit/>
-          </a:bodyPr>
-          <a:lstStyle xmlns:a="http://schemas.openxmlformats.org/drawingml/2006/main">
-            <a:defPPr algn="r">
-              <a:defRPr sz="1275" b="0">
-                <a:solidFill>
-                  <a:srgbClr val="087F8C"/>
-                </a:solidFill>
-                <a:latin typeface="Heiti TC"/>
-                <a:ea typeface="Heiti TC"/>
-                <a:cs typeface="Heiti TC"/>
-              </a:defRPr>
-            </a:defPPr>
-            <a:lvl1pPr algn="r">
-              <a:defRPr sz="1275" b="0">
-                <a:solidFill>
-                  <a:srgbClr val="087F8C"/>
-                </a:solidFill>
-                <a:latin typeface="Heiti TC"/>
-                <a:ea typeface="Heiti TC"/>
-                <a:cs typeface="Heiti TC"/>
-              </a:defRPr>
-            </a:lvl1pPr>
-            <a:lvl2pPr algn="r">
-              <a:defRPr sz="1275" b="0">
-                <a:solidFill>
-                  <a:srgbClr val="087F8C"/>
-                </a:solidFill>
-                <a:latin typeface="Heiti TC"/>
-                <a:ea typeface="Heiti TC"/>
-                <a:cs typeface="Heiti TC"/>
-              </a:defRPr>
-            </a:lvl2pPr>
-            <a:lvl3pPr algn="r">
-              <a:defRPr sz="1275" b="0">
-                <a:solidFill>
-                  <a:srgbClr val="087F8C"/>
-                </a:solidFill>
-                <a:latin typeface="Heiti TC"/>
-                <a:ea typeface="Heiti TC"/>
-                <a:cs typeface="Heiti TC"/>
-              </a:defRPr>
-            </a:lvl3pPr>
-            <a:lvl4pPr algn="r">
-              <a:defRPr sz="1275" b="0">
-                <a:solidFill>
-                  <a:srgbClr val="087F8C"/>
-                </a:solidFill>
-                <a:latin typeface="Heiti TC"/>
-                <a:ea typeface="Heiti TC"/>
-                <a:cs typeface="Heiti TC"/>
-              </a:defRPr>
-            </a:lvl4pPr>
-            <a:lvl5pPr algn="r">
-              <a:defRPr sz="1275" b="0">
-                <a:solidFill>
-                  <a:srgbClr val="087F8C"/>
-                </a:solidFill>
-                <a:latin typeface="Heiti TC"/>
-                <a:ea typeface="Heiti TC"/>
-                <a:cs typeface="Heiti TC"/>
-              </a:defRPr>
-            </a:lvl5pPr>
-            <a:lvl6pPr algn="r">
-              <a:defRPr sz="1275" b="0">
-                <a:solidFill>
-                  <a:srgbClr val="087F8C"/>
-                </a:solidFill>
-                <a:latin typeface="Heiti TC"/>
-                <a:ea typeface="Heiti TC"/>
-                <a:cs typeface="Heiti TC"/>
-              </a:defRPr>
-            </a:lvl6pPr>
-            <a:lvl7pPr algn="r">
-              <a:defRPr sz="1275" b="0">
-                <a:solidFill>
-                  <a:srgbClr val="087F8C"/>
-                </a:solidFill>
-                <a:latin typeface="Heiti TC"/>
-                <a:ea typeface="Heiti TC"/>
-                <a:cs typeface="Heiti TC"/>
-              </a:defRPr>
-            </a:lvl7pPr>
-            <a:lvl8pPr algn="r">
-              <a:defRPr sz="1275" b="0">
-                <a:solidFill>
-                  <a:srgbClr val="087F8C"/>
-                </a:solidFill>
-                <a:latin typeface="Heiti TC"/>
-                <a:ea typeface="Heiti TC"/>
-                <a:cs typeface="Heiti TC"/>
-              </a:defRPr>
-            </a:lvl8pPr>
-            <a:lvl9pPr algn="r">
-              <a:defRPr sz="1275" b="0">
-                <a:solidFill>
-                  <a:srgbClr val="087F8C"/>
-                </a:solidFill>
-                <a:latin typeface="Heiti TC"/>
-                <a:ea typeface="Heiti TC"/>
-                <a:cs typeface="Heiti TC"/>
-              </a:defRPr>
-            </a:lvl9pPr>
-          </a:lstStyle>
-          <a:p xmlns:a="http://schemas.openxmlformats.org/drawingml/2006/main">
-            <a:pPr algn="r">
-              <a:defRPr sz="1275" b="0">
-                <a:solidFill>
-                  <a:srgbClr val="087F8C"/>
-                </a:solidFill>
-                <a:latin typeface="Heiti TC"/>
-                <a:ea typeface="Heiti TC"/>
-                <a:cs typeface="Heiti TC"/>
-              </a:defRPr>
-            </a:pPr>
-            <a:r>
-              <a:rPr sz="1275" b="0">
-                <a:solidFill>
-                  <a:srgbClr val="087F8C"/>
-                </a:solidFill>
-                <a:latin typeface="Heiti TC"/>
-                <a:ea typeface="Heiti TC"/>
-                <a:cs typeface="Heiti TC"/>
-              </a:rPr>
-              <a:t>5 / 6</a:t>
-            </a:r>
-          </a:p>
-        </p:txBody>
-      </p:sp>
-      <p:sp>
-        <p:nvSpPr>
-          <p:cNvPr id="5" name="01">
-            <a:extLst xmlns:a="http://schemas.openxmlformats.org/drawingml/2006/main">
-              <a:ext uri="{FF2B5EF4-FFF2-40B4-BE49-F238E27FC236}">
-                <a16:creationId xmlns:a16="http://schemas.microsoft.com/office/drawing/2014/main" id="{967C346F-230D-4DDC-9F8E-CC0431AA40BC}"/>
-              </a:ext>
-            </a:extLst>
-          </p:cNvPr>
-          <p:cNvSpPr>
-            <a:spLocks xmlns:a="http://schemas.openxmlformats.org/drawingml/2006/main" noGrp="1"/>
-          </p:cNvSpPr>
-          <p:nvPr/>
-        </p:nvSpPr>
-        <p:spPr>
-          <a:xfrm xmlns:a="http://schemas.openxmlformats.org/drawingml/2006/main">
-            <a:off x="523875" y="1524000"/>
-            <a:ext cx="628650" cy="428625"/>
-          </a:xfrm>
-          <a:prstGeom xmlns:a="http://schemas.openxmlformats.org/drawingml/2006/main" prst="rect">
-            <a:avLst/>
-          </a:prstGeom>
-          <a:noFill xmlns:a="http://schemas.openxmlformats.org/drawingml/2006/main"/>
-          <a:ln xmlns:a="http://schemas.openxmlformats.org/drawingml/2006/main" w="0">
-            <a:noFill/>
-          </a:ln>
-        </p:spPr>
-        <p:txBody>
-          <a:bodyPr xmlns:a="http://schemas.openxmlformats.org/drawingml/2006/main" wrap="square" lIns="0" tIns="0" rIns="0" bIns="0" anchor="ctr">
-            <a:noAutofit/>
-          </a:bodyPr>
-          <a:lstStyle xmlns:a="http://schemas.openxmlformats.org/drawingml/2006/main">
-            <a:defPPr algn="l">
-              <a:defRPr sz="2325" b="1">
-                <a:solidFill>
-                  <a:srgbClr val="087F8C"/>
-                </a:solidFill>
-                <a:latin typeface="Heiti TC"/>
-                <a:ea typeface="Heiti TC"/>
-                <a:cs typeface="Heiti TC"/>
-              </a:defRPr>
-            </a:defPPr>
-            <a:lvl1pPr algn="l">
-              <a:defRPr sz="2325" b="1">
-                <a:solidFill>
-                  <a:srgbClr val="087F8C"/>
-                </a:solidFill>
-                <a:latin typeface="Heiti TC"/>
-                <a:ea typeface="Heiti TC"/>
-                <a:cs typeface="Heiti TC"/>
-              </a:defRPr>
-            </a:lvl1pPr>
-            <a:lvl2pPr algn="l">
-              <a:defRPr sz="2325" b="1">
-                <a:solidFill>
-                  <a:srgbClr val="087F8C"/>
-                </a:solidFill>
-                <a:latin typeface="Heiti TC"/>
-                <a:ea typeface="Heiti TC"/>
-                <a:cs typeface="Heiti TC"/>
-              </a:defRPr>
-            </a:lvl2pPr>
-            <a:lvl3pPr algn="l">
-              <a:defRPr sz="2325" b="1">
-                <a:solidFill>
-                  <a:srgbClr val="087F8C"/>
-                </a:solidFill>
-                <a:latin typeface="Heiti TC"/>
-                <a:ea typeface="Heiti TC"/>
-                <a:cs typeface="Heiti TC"/>
-              </a:defRPr>
-            </a:lvl3pPr>
-            <a:lvl4pPr algn="l">
-              <a:defRPr sz="2325" b="1">
-                <a:solidFill>
-                  <a:srgbClr val="087F8C"/>
-                </a:solidFill>
-                <a:latin typeface="Heiti TC"/>
-                <a:ea typeface="Heiti TC"/>
-                <a:cs typeface="Heiti TC"/>
-              </a:defRPr>
-            </a:lvl4pPr>
-            <a:lvl5pPr algn="l">
-              <a:defRPr sz="2325" b="1">
-                <a:solidFill>
-                  <a:srgbClr val="087F8C"/>
-                </a:solidFill>
-                <a:latin typeface="Heiti TC"/>
-                <a:ea typeface="Heiti TC"/>
-                <a:cs typeface="Heiti TC"/>
-              </a:defRPr>
-            </a:lvl5pPr>
-            <a:lvl6pPr algn="l">
-              <a:defRPr sz="2325" b="1">
-                <a:solidFill>
-                  <a:srgbClr val="087F8C"/>
-                </a:solidFill>
-                <a:latin typeface="Heiti TC"/>
-                <a:ea typeface="Heiti TC"/>
-                <a:cs typeface="Heiti TC"/>
-              </a:defRPr>
-            </a:lvl6pPr>
-            <a:lvl7pPr algn="l">
-              <a:defRPr sz="2325" b="1">
-                <a:solidFill>
-                  <a:srgbClr val="087F8C"/>
-                </a:solidFill>
-                <a:latin typeface="Heiti TC"/>
-                <a:ea typeface="Heiti TC"/>
-                <a:cs typeface="Heiti TC"/>
-              </a:defRPr>
-            </a:lvl7pPr>
-            <a:lvl8pPr algn="l">
-              <a:defRPr sz="2325" b="1">
-                <a:solidFill>
-                  <a:srgbClr val="087F8C"/>
-                </a:solidFill>
-                <a:latin typeface="Heiti TC"/>
-                <a:ea typeface="Heiti TC"/>
-                <a:cs typeface="Heiti TC"/>
-              </a:defRPr>
-            </a:lvl8pPr>
-            <a:lvl9pPr algn="l">
-              <a:defRPr sz="2325" b="1">
-                <a:solidFill>
-                  <a:srgbClr val="087F8C"/>
-                </a:solidFill>
-                <a:latin typeface="Heiti TC"/>
-                <a:ea typeface="Heiti TC"/>
-                <a:cs typeface="Heiti TC"/>
-              </a:defRPr>
-            </a:lvl9pPr>
-          </a:lstStyle>
-          <a:p xmlns:a="http://schemas.openxmlformats.org/drawingml/2006/main">
-            <a:pPr algn="l">
-              <a:defRPr sz="2325" b="1">
-                <a:solidFill>
-                  <a:srgbClr val="087F8C"/>
-                </a:solidFill>
-                <a:latin typeface="Heiti TC"/>
-                <a:ea typeface="Heiti TC"/>
-                <a:cs typeface="Heiti TC"/>
-              </a:defRPr>
-            </a:pPr>
-            <a:r>
-              <a:rPr sz="2325" b="1">
-                <a:solidFill>
-                  <a:srgbClr val="087F8C"/>
-                </a:solidFill>
-                <a:latin typeface="Heiti TC"/>
-                <a:ea typeface="Heiti TC"/>
-                <a:cs typeface="Heiti TC"/>
-              </a:rPr>
-              <a:t>01</a:t>
-            </a:r>
-          </a:p>
-        </p:txBody>
-      </p:sp>
-      <p:sp>
-        <p:nvSpPr>
-          <p:cNvPr id="6" name="可控的单意图路由">
-            <a:extLst xmlns:a="http://schemas.openxmlformats.org/drawingml/2006/main">
-              <a:ext uri="{FF2B5EF4-FFF2-40B4-BE49-F238E27FC236}">
-                <a16:creationId xmlns:a16="http://schemas.microsoft.com/office/drawing/2014/main" id="{507C7A82-3AC0-4BB4-8E90-CB652155071D}"/>
-              </a:ext>
-            </a:extLst>
-          </p:cNvPr>
-          <p:cNvSpPr>
-            <a:spLocks xmlns:a="http://schemas.openxmlformats.org/drawingml/2006/main" noGrp="1"/>
-          </p:cNvSpPr>
-          <p:nvPr/>
-        </p:nvSpPr>
-        <p:spPr>
-          <a:xfrm xmlns:a="http://schemas.openxmlformats.org/drawingml/2006/main">
-            <a:off x="1333500" y="1524000"/>
-            <a:ext cx="4191000" cy="381000"/>
-          </a:xfrm>
-          <a:prstGeom xmlns:a="http://schemas.openxmlformats.org/drawingml/2006/main" prst="rect">
-            <a:avLst/>
-          </a:prstGeom>
-          <a:noFill xmlns:a="http://schemas.openxmlformats.org/drawingml/2006/main"/>
-          <a:ln xmlns:a="http://schemas.openxmlformats.org/drawingml/2006/main" w="0">
-            <a:noFill/>
-          </a:ln>
-        </p:spPr>
-        <p:txBody>
-          <a:bodyPr xmlns:a="http://schemas.openxmlformats.org/drawingml/2006/main" wrap="square" lIns="0" tIns="0" rIns="0" bIns="0" anchor="ctr">
-            <a:noAutofit/>
-          </a:bodyPr>
-          <a:lstStyle xmlns:a="http://schemas.openxmlformats.org/drawingml/2006/main">
-            <a:defPPr algn="l">
-              <a:defRPr sz="2025" b="1">
-                <a:solidFill>
-                  <a:srgbClr val="102B40"/>
-                </a:solidFill>
-                <a:latin typeface="Heiti TC"/>
-                <a:ea typeface="Heiti TC"/>
-                <a:cs typeface="Heiti TC"/>
-              </a:defRPr>
-            </a:defPPr>
-            <a:lvl1pPr algn="l">
-              <a:defRPr sz="2025" b="1">
-                <a:solidFill>
-                  <a:srgbClr val="102B40"/>
-                </a:solidFill>
-                <a:latin typeface="Heiti TC"/>
-                <a:ea typeface="Heiti TC"/>
-                <a:cs typeface="Heiti TC"/>
-              </a:defRPr>
-            </a:lvl1pPr>
-            <a:lvl2pPr algn="l">
-              <a:defRPr sz="2025" b="1">
-                <a:solidFill>
-                  <a:srgbClr val="102B40"/>
-                </a:solidFill>
-                <a:latin typeface="Heiti TC"/>
-                <a:ea typeface="Heiti TC"/>
-                <a:cs typeface="Heiti TC"/>
-              </a:defRPr>
-            </a:lvl2pPr>
-            <a:lvl3pPr algn="l">
-              <a:defRPr sz="2025" b="1">
-                <a:solidFill>
-                  <a:srgbClr val="102B40"/>
-                </a:solidFill>
-                <a:latin typeface="Heiti TC"/>
-                <a:ea typeface="Heiti TC"/>
-                <a:cs typeface="Heiti TC"/>
-              </a:defRPr>
-            </a:lvl3pPr>
-            <a:lvl4pPr algn="l">
-              <a:defRPr sz="2025" b="1">
-                <a:solidFill>
-                  <a:srgbClr val="102B40"/>
-                </a:solidFill>
-                <a:latin typeface="Heiti TC"/>
-                <a:ea typeface="Heiti TC"/>
-                <a:cs typeface="Heiti TC"/>
-              </a:defRPr>
-            </a:lvl4pPr>
-            <a:lvl5pPr algn="l">
-              <a:defRPr sz="2025" b="1">
-                <a:solidFill>
-                  <a:srgbClr val="102B40"/>
-                </a:solidFill>
-                <a:latin typeface="Heiti TC"/>
-                <a:ea typeface="Heiti TC"/>
-                <a:cs typeface="Heiti TC"/>
-              </a:defRPr>
-            </a:lvl5pPr>
-            <a:lvl6pPr algn="l">
-              <a:defRPr sz="2025" b="1">
-                <a:solidFill>
-                  <a:srgbClr val="102B40"/>
-                </a:solidFill>
-                <a:latin typeface="Heiti TC"/>
-                <a:ea typeface="Heiti TC"/>
-                <a:cs typeface="Heiti TC"/>
-              </a:defRPr>
-            </a:lvl6pPr>
-            <a:lvl7pPr algn="l">
-              <a:defRPr sz="2025" b="1">
-                <a:solidFill>
-                  <a:srgbClr val="102B40"/>
-                </a:solidFill>
-                <a:latin typeface="Heiti TC"/>
-                <a:ea typeface="Heiti TC"/>
-                <a:cs typeface="Heiti TC"/>
-              </a:defRPr>
-            </a:lvl7pPr>
-            <a:lvl8pPr algn="l">
-              <a:defRPr sz="2025" b="1">
-                <a:solidFill>
-                  <a:srgbClr val="102B40"/>
-                </a:solidFill>
-                <a:latin typeface="Heiti TC"/>
-                <a:ea typeface="Heiti TC"/>
-                <a:cs typeface="Heiti TC"/>
-              </a:defRPr>
-            </a:lvl8pPr>
-            <a:lvl9pPr algn="l">
-              <a:defRPr sz="2025" b="1">
-                <a:solidFill>
-                  <a:srgbClr val="102B40"/>
-                </a:solidFill>
-                <a:latin typeface="Heiti TC"/>
-                <a:ea typeface="Heiti TC"/>
-                <a:cs typeface="Heiti TC"/>
-              </a:defRPr>
-            </a:lvl9pPr>
-          </a:lstStyle>
-          <a:p xmlns:a="http://schemas.openxmlformats.org/drawingml/2006/main">
-            <a:pPr algn="l">
-              <a:defRPr sz="2025" b="1">
-                <a:solidFill>
-                  <a:srgbClr val="102B40"/>
-                </a:solidFill>
-                <a:latin typeface="Heiti TC"/>
-                <a:ea typeface="Heiti TC"/>
-                <a:cs typeface="Heiti TC"/>
-              </a:defRPr>
-            </a:pPr>
-            <a:r>
-              <a:rPr sz="2025" b="1">
-                <a:solidFill>
-                  <a:srgbClr val="102B40"/>
-                </a:solidFill>
-                <a:latin typeface="Heiti TC"/>
-                <a:ea typeface="Heiti TC"/>
-                <a:cs typeface="Heiti TC"/>
-              </a:rPr>
-              <a:t>Markdown 划分父块</a:t>
-            </a:r>
-          </a:p>
-        </p:txBody>
-      </p:sp>
-      <p:sp>
-        <p:nvSpPr>
-          <p:cNvPr id="7" name="明确寒暄与转人工走 Python 规则，其余由 LLM 分类">
-            <a:extLst xmlns:a="http://schemas.openxmlformats.org/drawingml/2006/main">
-              <a:ext uri="{FF2B5EF4-FFF2-40B4-BE49-F238E27FC236}">
-                <a16:creationId xmlns:a16="http://schemas.microsoft.com/office/drawing/2014/main" id="{6A0C4F56-EE34-45F0-8F13-ACDAB2A03214}"/>
-              </a:ext>
-            </a:extLst>
-          </p:cNvPr>
-          <p:cNvSpPr>
-            <a:spLocks xmlns:a="http://schemas.openxmlformats.org/drawingml/2006/main" noGrp="1"/>
-          </p:cNvSpPr>
-          <p:nvPr/>
-        </p:nvSpPr>
-        <p:spPr>
-          <a:xfrm xmlns:a="http://schemas.openxmlformats.org/drawingml/2006/main">
-            <a:off x="1333500" y="1971675"/>
-            <a:ext cx="10287000" cy="323850"/>
-          </a:xfrm>
-          <a:prstGeom xmlns:a="http://schemas.openxmlformats.org/drawingml/2006/main" prst="rect">
-            <a:avLst/>
-          </a:prstGeom>
-          <a:noFill xmlns:a="http://schemas.openxmlformats.org/drawingml/2006/main"/>
-          <a:ln xmlns:a="http://schemas.openxmlformats.org/drawingml/2006/main" w="0">
-            <a:noFill/>
-          </a:ln>
-        </p:spPr>
-        <p:txBody>
-          <a:bodyPr xmlns:a="http://schemas.openxmlformats.org/drawingml/2006/main" wrap="square" lIns="0" tIns="0" rIns="0" bIns="0" anchor="ctr">
-            <a:noAutofit/>
-          </a:bodyPr>
-          <a:lstStyle xmlns:a="http://schemas.openxmlformats.org/drawingml/2006/main">
-            <a:defPPr algn="l">
-              <a:defRPr sz="1800" b="0">
-                <a:solidFill>
-                  <a:srgbClr val="102B40"/>
-                </a:solidFill>
-                <a:latin typeface="Heiti TC"/>
-                <a:ea typeface="Heiti TC"/>
-                <a:cs typeface="Heiti TC"/>
-              </a:defRPr>
-            </a:defPPr>
-            <a:lvl1pPr algn="l">
-              <a:defRPr sz="1800" b="0">
-                <a:solidFill>
-                  <a:srgbClr val="102B40"/>
-                </a:solidFill>
-                <a:latin typeface="Heiti TC"/>
-                <a:ea typeface="Heiti TC"/>
-                <a:cs typeface="Heiti TC"/>
-              </a:defRPr>
-            </a:lvl1pPr>
-            <a:lvl2pPr algn="l">
-              <a:defRPr sz="1800" b="0">
-                <a:solidFill>
-                  <a:srgbClr val="102B40"/>
-                </a:solidFill>
-                <a:latin typeface="Heiti TC"/>
-                <a:ea typeface="Heiti TC"/>
-                <a:cs typeface="Heiti TC"/>
-              </a:defRPr>
-            </a:lvl2pPr>
-            <a:lvl3pPr algn="l">
-              <a:defRPr sz="1800" b="0">
-                <a:solidFill>
-                  <a:srgbClr val="102B40"/>
-                </a:solidFill>
-                <a:latin typeface="Heiti TC"/>
-                <a:ea typeface="Heiti TC"/>
-                <a:cs typeface="Heiti TC"/>
-              </a:defRPr>
-            </a:lvl3pPr>
-            <a:lvl4pPr algn="l">
-              <a:defRPr sz="1800" b="0">
-                <a:solidFill>
-                  <a:srgbClr val="102B40"/>
-                </a:solidFill>
-                <a:latin typeface="Heiti TC"/>
-                <a:ea typeface="Heiti TC"/>
-                <a:cs typeface="Heiti TC"/>
-              </a:defRPr>
-            </a:lvl4pPr>
-            <a:lvl5pPr algn="l">
-              <a:defRPr sz="1800" b="0">
-                <a:solidFill>
-                  <a:srgbClr val="102B40"/>
-                </a:solidFill>
-                <a:latin typeface="Heiti TC"/>
-                <a:ea typeface="Heiti TC"/>
-                <a:cs typeface="Heiti TC"/>
-              </a:defRPr>
-            </a:lvl5pPr>
-            <a:lvl6pPr algn="l">
-              <a:defRPr sz="1800" b="0">
-                <a:solidFill>
-                  <a:srgbClr val="102B40"/>
-                </a:solidFill>
-                <a:latin typeface="Heiti TC"/>
-                <a:ea typeface="Heiti TC"/>
-                <a:cs typeface="Heiti TC"/>
-              </a:defRPr>
-            </a:lvl6pPr>
-            <a:lvl7pPr algn="l">
-              <a:defRPr sz="1800" b="0">
-                <a:solidFill>
-                  <a:srgbClr val="102B40"/>
-                </a:solidFill>
-                <a:latin typeface="Heiti TC"/>
-                <a:ea typeface="Heiti TC"/>
-                <a:cs typeface="Heiti TC"/>
-              </a:defRPr>
-            </a:lvl7pPr>
-            <a:lvl8pPr algn="l">
-              <a:defRPr sz="1800" b="0">
-                <a:solidFill>
-                  <a:srgbClr val="102B40"/>
-                </a:solidFill>
-                <a:latin typeface="Heiti TC"/>
-                <a:ea typeface="Heiti TC"/>
-                <a:cs typeface="Heiti TC"/>
-              </a:defRPr>
-            </a:lvl8pPr>
-            <a:lvl9pPr algn="l">
-              <a:defRPr sz="1800" b="0">
-                <a:solidFill>
-                  <a:srgbClr val="102B40"/>
-                </a:solidFill>
-                <a:latin typeface="Heiti TC"/>
-                <a:ea typeface="Heiti TC"/>
-                <a:cs typeface="Heiti TC"/>
-              </a:defRPr>
-            </a:lvl9pPr>
-          </a:lstStyle>
-          <a:p xmlns:a="http://schemas.openxmlformats.org/drawingml/2006/main">
-            <a:pPr algn="l">
-              <a:defRPr sz="1800" b="0">
-                <a:solidFill>
-                  <a:srgbClr val="102B40"/>
-                </a:solidFill>
-                <a:latin typeface="Heiti TC"/>
-                <a:ea typeface="Heiti TC"/>
-                <a:cs typeface="Heiti TC"/>
-              </a:defRPr>
-            </a:pPr>
-            <a:r>
-              <a:rPr sz="1800" b="0">
-                <a:solidFill>
-                  <a:srgbClr val="102B40"/>
-                </a:solidFill>
-                <a:latin typeface="Heiti TC"/>
-                <a:ea typeface="Heiti TC"/>
-                <a:cs typeface="Heiti TC"/>
-              </a:rPr>
-              <a:t>按标题层级和完整主题划分父块，保留标题路径与来源</a:t>
-            </a:r>
-          </a:p>
-        </p:txBody>
-      </p:sp>
-      <p:sp>
-        <p:nvSpPr>
-          <p:cNvPr id="8" name="多轮上下文与 SSE 节点进度可追踪">
-            <a:extLst xmlns:a="http://schemas.openxmlformats.org/drawingml/2006/main">
-              <a:ext uri="{FF2B5EF4-FFF2-40B4-BE49-F238E27FC236}">
-                <a16:creationId xmlns:a16="http://schemas.microsoft.com/office/drawing/2014/main" id="{FA3B2B4C-EB04-4428-B30D-8A479D709222}"/>
-              </a:ext>
-            </a:extLst>
-          </p:cNvPr>
-          <p:cNvSpPr>
-            <a:spLocks xmlns:a="http://schemas.openxmlformats.org/drawingml/2006/main" noGrp="1"/>
-          </p:cNvSpPr>
-          <p:nvPr/>
-        </p:nvSpPr>
-        <p:spPr>
-          <a:xfrm xmlns:a="http://schemas.openxmlformats.org/drawingml/2006/main">
-            <a:off x="6096000" y="1524000"/>
-            <a:ext cx="5476875" cy="400050"/>
-          </a:xfrm>
-          <a:prstGeom xmlns:a="http://schemas.openxmlformats.org/drawingml/2006/main" prst="rect">
-            <a:avLst/>
-          </a:prstGeom>
-          <a:noFill xmlns:a="http://schemas.openxmlformats.org/drawingml/2006/main"/>
-          <a:ln xmlns:a="http://schemas.openxmlformats.org/drawingml/2006/main" w="0">
-            <a:noFill/>
-          </a:ln>
-        </p:spPr>
-        <p:txBody>
-          <a:bodyPr xmlns:a="http://schemas.openxmlformats.org/drawingml/2006/main" wrap="square" lIns="0" tIns="0" rIns="0" bIns="0" anchor="ctr">
-            <a:noAutofit/>
-          </a:bodyPr>
-          <a:lstStyle xmlns:a="http://schemas.openxmlformats.org/drawingml/2006/main">
-            <a:defPPr algn="l">
-              <a:defRPr sz="1725" b="0">
-                <a:solidFill>
-                  <a:srgbClr val="087F8C"/>
-                </a:solidFill>
-                <a:latin typeface="Heiti TC"/>
-                <a:ea typeface="Heiti TC"/>
-                <a:cs typeface="Heiti TC"/>
-              </a:defRPr>
-            </a:defPPr>
-            <a:lvl1pPr algn="l">
-              <a:defRPr sz="1725" b="0">
-                <a:solidFill>
-                  <a:srgbClr val="087F8C"/>
-                </a:solidFill>
-                <a:latin typeface="Heiti TC"/>
-                <a:ea typeface="Heiti TC"/>
-                <a:cs typeface="Heiti TC"/>
-              </a:defRPr>
-            </a:lvl1pPr>
-            <a:lvl2pPr algn="l">
-              <a:defRPr sz="1725" b="0">
-                <a:solidFill>
-                  <a:srgbClr val="087F8C"/>
-                </a:solidFill>
-                <a:latin typeface="Heiti TC"/>
-                <a:ea typeface="Heiti TC"/>
-                <a:cs typeface="Heiti TC"/>
-              </a:defRPr>
-            </a:lvl2pPr>
-            <a:lvl3pPr algn="l">
-              <a:defRPr sz="1725" b="0">
-                <a:solidFill>
-                  <a:srgbClr val="087F8C"/>
-                </a:solidFill>
-                <a:latin typeface="Heiti TC"/>
-                <a:ea typeface="Heiti TC"/>
-                <a:cs typeface="Heiti TC"/>
-              </a:defRPr>
-            </a:lvl3pPr>
-            <a:lvl4pPr algn="l">
-              <a:defRPr sz="1725" b="0">
-                <a:solidFill>
-                  <a:srgbClr val="087F8C"/>
-                </a:solidFill>
-                <a:latin typeface="Heiti TC"/>
-                <a:ea typeface="Heiti TC"/>
-                <a:cs typeface="Heiti TC"/>
-              </a:defRPr>
-            </a:lvl4pPr>
-            <a:lvl5pPr algn="l">
-              <a:defRPr sz="1725" b="0">
-                <a:solidFill>
-                  <a:srgbClr val="087F8C"/>
-                </a:solidFill>
-                <a:latin typeface="Heiti TC"/>
-                <a:ea typeface="Heiti TC"/>
-                <a:cs typeface="Heiti TC"/>
-              </a:defRPr>
-            </a:lvl5pPr>
-            <a:lvl6pPr algn="l">
-              <a:defRPr sz="1725" b="0">
-                <a:solidFill>
-                  <a:srgbClr val="087F8C"/>
-                </a:solidFill>
-                <a:latin typeface="Heiti TC"/>
-                <a:ea typeface="Heiti TC"/>
-                <a:cs typeface="Heiti TC"/>
-              </a:defRPr>
-            </a:lvl6pPr>
-            <a:lvl7pPr algn="l">
-              <a:defRPr sz="1725" b="0">
-                <a:solidFill>
-                  <a:srgbClr val="087F8C"/>
-                </a:solidFill>
-                <a:latin typeface="Heiti TC"/>
-                <a:ea typeface="Heiti TC"/>
-                <a:cs typeface="Heiti TC"/>
-              </a:defRPr>
-            </a:lvl7pPr>
-            <a:lvl8pPr algn="l">
-              <a:defRPr sz="1725" b="0">
-                <a:solidFill>
-                  <a:srgbClr val="087F8C"/>
-                </a:solidFill>
-                <a:latin typeface="Heiti TC"/>
-                <a:ea typeface="Heiti TC"/>
-                <a:cs typeface="Heiti TC"/>
-              </a:defRPr>
-            </a:lvl8pPr>
-            <a:lvl9pPr algn="l">
-              <a:defRPr sz="1725" b="0">
-                <a:solidFill>
-                  <a:srgbClr val="087F8C"/>
-                </a:solidFill>
-                <a:latin typeface="Heiti TC"/>
-                <a:ea typeface="Heiti TC"/>
-                <a:cs typeface="Heiti TC"/>
-              </a:defRPr>
-            </a:lvl9pPr>
-          </a:lstStyle>
-          <a:p xmlns:a="http://schemas.openxmlformats.org/drawingml/2006/main">
-            <a:pPr algn="l">
-              <a:defRPr sz="1725" b="0">
-                <a:solidFill>
-                  <a:srgbClr val="087F8C"/>
-                </a:solidFill>
-                <a:latin typeface="Heiti TC"/>
-                <a:ea typeface="Heiti TC"/>
-                <a:cs typeface="Heiti TC"/>
-              </a:defRPr>
-            </a:pPr>
-            <a:r>
-              <a:rPr sz="1725" b="0">
-                <a:solidFill>
-                  <a:srgbClr val="087F8C"/>
-                </a:solidFill>
-                <a:latin typeface="Heiti TC"/>
-                <a:ea typeface="Heiti TC"/>
-                <a:cs typeface="Heiti TC"/>
-              </a:rPr>
-              <a:t>父块保留完整业务语境</a:t>
-            </a:r>
-          </a:p>
-        </p:txBody>
-      </p:sp>
-      <p:cxnSp>
-        <p:nvCxnSpPr>
-          <p:cNvPr id="9" name="">
-            <a:extLst xmlns:a="http://schemas.openxmlformats.org/drawingml/2006/main">
-              <a:ext uri="{FF2B5EF4-FFF2-40B4-BE49-F238E27FC236}">
-                <a16:creationId xmlns:a16="http://schemas.microsoft.com/office/drawing/2014/main" id="{41C77463-19D4-440C-9806-AC52B5D3D7C7}"/>
-              </a:ext>
-            </a:extLst>
-          </p:cNvPr>
-          <p:cNvCxnSpPr/>
-          <p:nvPr/>
-        </p:nvCxnSpPr>
-        <p:spPr>
-          <a:xfrm xmlns:a="http://schemas.openxmlformats.org/drawingml/2006/main" flipH="0" flipV="0">
-            <a:off x="1333500" y="2457450"/>
-            <a:ext cx="10334625" cy="0"/>
-          </a:xfrm>
-          <a:prstGeom xmlns:a="http://schemas.openxmlformats.org/drawingml/2006/main" prst="straightConnector1">
-            <a:avLst/>
-          </a:prstGeom>
-          <a:ln xmlns:a="http://schemas.openxmlformats.org/drawingml/2006/main" w="15240">
-            <a:solidFill>
-              <a:srgbClr val="B6C8D6"/>
-            </a:solidFill>
-            <a:prstDash val="solid"/>
-            <a:tailEnd type="none" w="med" len="med"/>
-          </a:ln>
-        </p:spPr>
-      </p:cxnSp>
-      <p:sp>
-        <p:nvSpPr>
-          <p:cNvPr id="10" name="02">
-            <a:extLst xmlns:a="http://schemas.openxmlformats.org/drawingml/2006/main">
-              <a:ext uri="{FF2B5EF4-FFF2-40B4-BE49-F238E27FC236}">
-                <a16:creationId xmlns:a16="http://schemas.microsoft.com/office/drawing/2014/main" id="{6C032874-7E83-4135-8B6A-7E193C3F1773}"/>
-              </a:ext>
-            </a:extLst>
-          </p:cNvPr>
-          <p:cNvSpPr>
-            <a:spLocks xmlns:a="http://schemas.openxmlformats.org/drawingml/2006/main" noGrp="1"/>
-          </p:cNvSpPr>
-          <p:nvPr/>
-        </p:nvSpPr>
-        <p:spPr>
-          <a:xfrm xmlns:a="http://schemas.openxmlformats.org/drawingml/2006/main">
-            <a:off x="523875" y="2628900"/>
-            <a:ext cx="628650" cy="428625"/>
-          </a:xfrm>
-          <a:prstGeom xmlns:a="http://schemas.openxmlformats.org/drawingml/2006/main" prst="rect">
-            <a:avLst/>
-          </a:prstGeom>
-          <a:noFill xmlns:a="http://schemas.openxmlformats.org/drawingml/2006/main"/>
-          <a:ln xmlns:a="http://schemas.openxmlformats.org/drawingml/2006/main" w="0">
-            <a:noFill/>
-          </a:ln>
-        </p:spPr>
-        <p:txBody>
-          <a:bodyPr xmlns:a="http://schemas.openxmlformats.org/drawingml/2006/main" wrap="square" lIns="0" tIns="0" rIns="0" bIns="0" anchor="ctr">
-            <a:noAutofit/>
-          </a:bodyPr>
-          <a:lstStyle xmlns:a="http://schemas.openxmlformats.org/drawingml/2006/main">
-            <a:defPPr algn="l">
-              <a:defRPr sz="2325" b="1">
-                <a:solidFill>
-                  <a:srgbClr val="087F8C"/>
-                </a:solidFill>
-                <a:latin typeface="Heiti TC"/>
-                <a:ea typeface="Heiti TC"/>
-                <a:cs typeface="Heiti TC"/>
-              </a:defRPr>
-            </a:defPPr>
-            <a:lvl1pPr algn="l">
-              <a:defRPr sz="2325" b="1">
-                <a:solidFill>
-                  <a:srgbClr val="087F8C"/>
-                </a:solidFill>
-                <a:latin typeface="Heiti TC"/>
-                <a:ea typeface="Heiti TC"/>
-                <a:cs typeface="Heiti TC"/>
-              </a:defRPr>
-            </a:lvl1pPr>
-            <a:lvl2pPr algn="l">
-              <a:defRPr sz="2325" b="1">
-                <a:solidFill>
-                  <a:srgbClr val="087F8C"/>
-                </a:solidFill>
-                <a:latin typeface="Heiti TC"/>
-                <a:ea typeface="Heiti TC"/>
-                <a:cs typeface="Heiti TC"/>
-              </a:defRPr>
-            </a:lvl2pPr>
-            <a:lvl3pPr algn="l">
-              <a:defRPr sz="2325" b="1">
-                <a:solidFill>
-                  <a:srgbClr val="087F8C"/>
-                </a:solidFill>
-                <a:latin typeface="Heiti TC"/>
-                <a:ea typeface="Heiti TC"/>
-                <a:cs typeface="Heiti TC"/>
-              </a:defRPr>
-            </a:lvl3pPr>
-            <a:lvl4pPr algn="l">
-              <a:defRPr sz="2325" b="1">
-                <a:solidFill>
-                  <a:srgbClr val="087F8C"/>
-                </a:solidFill>
-                <a:latin typeface="Heiti TC"/>
-                <a:ea typeface="Heiti TC"/>
-                <a:cs typeface="Heiti TC"/>
-              </a:defRPr>
-            </a:lvl4pPr>
-            <a:lvl5pPr algn="l">
-              <a:defRPr sz="2325" b="1">
-                <a:solidFill>
-                  <a:srgbClr val="087F8C"/>
-                </a:solidFill>
-                <a:latin typeface="Heiti TC"/>
-                <a:ea typeface="Heiti TC"/>
-                <a:cs typeface="Heiti TC"/>
-              </a:defRPr>
-            </a:lvl5pPr>
-            <a:lvl6pPr algn="l">
-              <a:defRPr sz="2325" b="1">
-                <a:solidFill>
-                  <a:srgbClr val="087F8C"/>
-                </a:solidFill>
-                <a:latin typeface="Heiti TC"/>
-                <a:ea typeface="Heiti TC"/>
-                <a:cs typeface="Heiti TC"/>
-              </a:defRPr>
-            </a:lvl6pPr>
-            <a:lvl7pPr algn="l">
-              <a:defRPr sz="2325" b="1">
-                <a:solidFill>
-                  <a:srgbClr val="087F8C"/>
-                </a:solidFill>
-                <a:latin typeface="Heiti TC"/>
-                <a:ea typeface="Heiti TC"/>
-                <a:cs typeface="Heiti TC"/>
-              </a:defRPr>
-            </a:lvl7pPr>
-            <a:lvl8pPr algn="l">
-              <a:defRPr sz="2325" b="1">
-                <a:solidFill>
-                  <a:srgbClr val="087F8C"/>
-                </a:solidFill>
-                <a:latin typeface="Heiti TC"/>
-                <a:ea typeface="Heiti TC"/>
-                <a:cs typeface="Heiti TC"/>
-              </a:defRPr>
-            </a:lvl8pPr>
-            <a:lvl9pPr algn="l">
-              <a:defRPr sz="2325" b="1">
-                <a:solidFill>
-                  <a:srgbClr val="087F8C"/>
-                </a:solidFill>
-                <a:latin typeface="Heiti TC"/>
-                <a:ea typeface="Heiti TC"/>
-                <a:cs typeface="Heiti TC"/>
-              </a:defRPr>
-            </a:lvl9pPr>
-          </a:lstStyle>
-          <a:p xmlns:a="http://schemas.openxmlformats.org/drawingml/2006/main">
-            <a:pPr algn="l">
-              <a:defRPr sz="2325" b="1">
-                <a:solidFill>
-                  <a:srgbClr val="087F8C"/>
-                </a:solidFill>
-                <a:latin typeface="Heiti TC"/>
-                <a:ea typeface="Heiti TC"/>
-                <a:cs typeface="Heiti TC"/>
-              </a:defRPr>
-            </a:pPr>
-            <a:r>
-              <a:rPr sz="2325" b="1">
-                <a:solidFill>
-                  <a:srgbClr val="087F8C"/>
-                </a:solidFill>
-                <a:latin typeface="Heiti TC"/>
-                <a:ea typeface="Heiti TC"/>
-                <a:cs typeface="Heiti TC"/>
-              </a:rPr>
-              <a:t>02</a:t>
-            </a:r>
-          </a:p>
-        </p:txBody>
-      </p:sp>
-      <p:sp>
-        <p:nvSpPr>
-          <p:cNvPr id="11" name="分层检索与独立精排">
-            <a:extLst xmlns:a="http://schemas.openxmlformats.org/drawingml/2006/main">
-              <a:ext uri="{FF2B5EF4-FFF2-40B4-BE49-F238E27FC236}">
-                <a16:creationId xmlns:a16="http://schemas.microsoft.com/office/drawing/2014/main" id="{7EC423B6-302D-441D-B6FA-1EE6FFEA6A37}"/>
-              </a:ext>
-            </a:extLst>
-          </p:cNvPr>
-          <p:cNvSpPr>
-            <a:spLocks xmlns:a="http://schemas.openxmlformats.org/drawingml/2006/main" noGrp="1"/>
-          </p:cNvSpPr>
-          <p:nvPr/>
-        </p:nvSpPr>
-        <p:spPr>
-          <a:xfrm xmlns:a="http://schemas.openxmlformats.org/drawingml/2006/main">
-            <a:off x="1333500" y="2628900"/>
-            <a:ext cx="4191000" cy="381000"/>
-          </a:xfrm>
-          <a:prstGeom xmlns:a="http://schemas.openxmlformats.org/drawingml/2006/main" prst="rect">
-            <a:avLst/>
-          </a:prstGeom>
-          <a:noFill xmlns:a="http://schemas.openxmlformats.org/drawingml/2006/main"/>
-          <a:ln xmlns:a="http://schemas.openxmlformats.org/drawingml/2006/main" w="0">
-            <a:noFill/>
-          </a:ln>
-        </p:spPr>
-        <p:txBody>
-          <a:bodyPr xmlns:a="http://schemas.openxmlformats.org/drawingml/2006/main" wrap="square" lIns="0" tIns="0" rIns="0" bIns="0" anchor="ctr">
-            <a:noAutofit/>
-          </a:bodyPr>
-          <a:lstStyle xmlns:a="http://schemas.openxmlformats.org/drawingml/2006/main">
-            <a:defPPr algn="l">
-              <a:defRPr sz="2025" b="1">
-                <a:solidFill>
-                  <a:srgbClr val="102B40"/>
-                </a:solidFill>
-                <a:latin typeface="Heiti TC"/>
-                <a:ea typeface="Heiti TC"/>
-                <a:cs typeface="Heiti TC"/>
-              </a:defRPr>
-            </a:defPPr>
-            <a:lvl1pPr algn="l">
-              <a:defRPr sz="2025" b="1">
-                <a:solidFill>
-                  <a:srgbClr val="102B40"/>
-                </a:solidFill>
-                <a:latin typeface="Heiti TC"/>
-                <a:ea typeface="Heiti TC"/>
-                <a:cs typeface="Heiti TC"/>
-              </a:defRPr>
-            </a:lvl1pPr>
-            <a:lvl2pPr algn="l">
-              <a:defRPr sz="2025" b="1">
-                <a:solidFill>
-                  <a:srgbClr val="102B40"/>
-                </a:solidFill>
-                <a:latin typeface="Heiti TC"/>
-                <a:ea typeface="Heiti TC"/>
-                <a:cs typeface="Heiti TC"/>
-              </a:defRPr>
-            </a:lvl2pPr>
-            <a:lvl3pPr algn="l">
-              <a:defRPr sz="2025" b="1">
-                <a:solidFill>
-                  <a:srgbClr val="102B40"/>
-                </a:solidFill>
-                <a:latin typeface="Heiti TC"/>
-                <a:ea typeface="Heiti TC"/>
-                <a:cs typeface="Heiti TC"/>
-              </a:defRPr>
-            </a:lvl3pPr>
-            <a:lvl4pPr algn="l">
-              <a:defRPr sz="2025" b="1">
-                <a:solidFill>
-                  <a:srgbClr val="102B40"/>
-                </a:solidFill>
-                <a:latin typeface="Heiti TC"/>
-                <a:ea typeface="Heiti TC"/>
-                <a:cs typeface="Heiti TC"/>
-              </a:defRPr>
-            </a:lvl4pPr>
-            <a:lvl5pPr algn="l">
-              <a:defRPr sz="2025" b="1">
-                <a:solidFill>
-                  <a:srgbClr val="102B40"/>
-                </a:solidFill>
-                <a:latin typeface="Heiti TC"/>
-                <a:ea typeface="Heiti TC"/>
-                <a:cs typeface="Heiti TC"/>
-              </a:defRPr>
-            </a:lvl5pPr>
-            <a:lvl6pPr algn="l">
-              <a:defRPr sz="2025" b="1">
-                <a:solidFill>
-                  <a:srgbClr val="102B40"/>
-                </a:solidFill>
-                <a:latin typeface="Heiti TC"/>
-                <a:ea typeface="Heiti TC"/>
-                <a:cs typeface="Heiti TC"/>
-              </a:defRPr>
-            </a:lvl6pPr>
-            <a:lvl7pPr algn="l">
-              <a:defRPr sz="2025" b="1">
-                <a:solidFill>
-                  <a:srgbClr val="102B40"/>
-                </a:solidFill>
-                <a:latin typeface="Heiti TC"/>
-                <a:ea typeface="Heiti TC"/>
-                <a:cs typeface="Heiti TC"/>
-              </a:defRPr>
-            </a:lvl7pPr>
-            <a:lvl8pPr algn="l">
-              <a:defRPr sz="2025" b="1">
-                <a:solidFill>
-                  <a:srgbClr val="102B40"/>
-                </a:solidFill>
-                <a:latin typeface="Heiti TC"/>
-                <a:ea typeface="Heiti TC"/>
-                <a:cs typeface="Heiti TC"/>
-              </a:defRPr>
-            </a:lvl8pPr>
-            <a:lvl9pPr algn="l">
-              <a:defRPr sz="2025" b="1">
-                <a:solidFill>
-                  <a:srgbClr val="102B40"/>
-                </a:solidFill>
-                <a:latin typeface="Heiti TC"/>
-                <a:ea typeface="Heiti TC"/>
-                <a:cs typeface="Heiti TC"/>
-              </a:defRPr>
-            </a:lvl9pPr>
-          </a:lstStyle>
-          <a:p xmlns:a="http://schemas.openxmlformats.org/drawingml/2006/main">
-            <a:pPr algn="l">
-              <a:defRPr sz="2025" b="1">
-                <a:solidFill>
-                  <a:srgbClr val="102B40"/>
-                </a:solidFill>
-                <a:latin typeface="Heiti TC"/>
-                <a:ea typeface="Heiti TC"/>
-                <a:cs typeface="Heiti TC"/>
-              </a:defRPr>
-            </a:pPr>
-            <a:r>
-              <a:rPr sz="2025" b="1">
-                <a:solidFill>
-                  <a:srgbClr val="102B40"/>
-                </a:solidFill>
-                <a:latin typeface="Heiti TC"/>
-                <a:ea typeface="Heiti TC"/>
-                <a:cs typeface="Heiti TC"/>
-              </a:rPr>
-              <a:t>父块内部切分子块</a:t>
-            </a:r>
-          </a:p>
-        </p:txBody>
-      </p:sp>
-      <p:sp>
-        <p:nvSpPr>
-          <p:cNvPr id="12" name="FAQ 优先，未明确命中再走原查询 + HyDE 混合检索">
-            <a:extLst xmlns:a="http://schemas.openxmlformats.org/drawingml/2006/main">
-              <a:ext uri="{FF2B5EF4-FFF2-40B4-BE49-F238E27FC236}">
-                <a16:creationId xmlns:a16="http://schemas.microsoft.com/office/drawing/2014/main" id="{9D59015E-58F2-4924-961C-3345E5C72580}"/>
-              </a:ext>
-            </a:extLst>
-          </p:cNvPr>
-          <p:cNvSpPr>
-            <a:spLocks xmlns:a="http://schemas.openxmlformats.org/drawingml/2006/main" noGrp="1"/>
-          </p:cNvSpPr>
-          <p:nvPr/>
-        </p:nvSpPr>
-        <p:spPr>
-          <a:xfrm xmlns:a="http://schemas.openxmlformats.org/drawingml/2006/main">
-            <a:off x="1333500" y="3076575"/>
-            <a:ext cx="10287000" cy="323850"/>
-          </a:xfrm>
-          <a:prstGeom xmlns:a="http://schemas.openxmlformats.org/drawingml/2006/main" prst="rect">
-            <a:avLst/>
-          </a:prstGeom>
-          <a:noFill xmlns:a="http://schemas.openxmlformats.org/drawingml/2006/main"/>
-          <a:ln xmlns:a="http://schemas.openxmlformats.org/drawingml/2006/main" w="0">
-            <a:noFill/>
-          </a:ln>
-        </p:spPr>
-        <p:txBody>
-          <a:bodyPr xmlns:a="http://schemas.openxmlformats.org/drawingml/2006/main" wrap="square" lIns="0" tIns="0" rIns="0" bIns="0" anchor="ctr">
-            <a:noAutofit/>
-          </a:bodyPr>
-          <a:lstStyle xmlns:a="http://schemas.openxmlformats.org/drawingml/2006/main">
-            <a:defPPr algn="l">
-              <a:defRPr sz="1800" b="0">
-                <a:solidFill>
-                  <a:srgbClr val="102B40"/>
-                </a:solidFill>
-                <a:latin typeface="Heiti TC"/>
-                <a:ea typeface="Heiti TC"/>
-                <a:cs typeface="Heiti TC"/>
-              </a:defRPr>
-            </a:defPPr>
-            <a:lvl1pPr algn="l">
-              <a:defRPr sz="1800" b="0">
-                <a:solidFill>
-                  <a:srgbClr val="102B40"/>
-                </a:solidFill>
-                <a:latin typeface="Heiti TC"/>
-                <a:ea typeface="Heiti TC"/>
-                <a:cs typeface="Heiti TC"/>
-              </a:defRPr>
-            </a:lvl1pPr>
-            <a:lvl2pPr algn="l">
-              <a:defRPr sz="1800" b="0">
-                <a:solidFill>
-                  <a:srgbClr val="102B40"/>
-                </a:solidFill>
-                <a:latin typeface="Heiti TC"/>
-                <a:ea typeface="Heiti TC"/>
-                <a:cs typeface="Heiti TC"/>
-              </a:defRPr>
-            </a:lvl2pPr>
-            <a:lvl3pPr algn="l">
-              <a:defRPr sz="1800" b="0">
-                <a:solidFill>
-                  <a:srgbClr val="102B40"/>
-                </a:solidFill>
-                <a:latin typeface="Heiti TC"/>
-                <a:ea typeface="Heiti TC"/>
-                <a:cs typeface="Heiti TC"/>
-              </a:defRPr>
-            </a:lvl3pPr>
-            <a:lvl4pPr algn="l">
-              <a:defRPr sz="1800" b="0">
-                <a:solidFill>
-                  <a:srgbClr val="102B40"/>
-                </a:solidFill>
-                <a:latin typeface="Heiti TC"/>
-                <a:ea typeface="Heiti TC"/>
-                <a:cs typeface="Heiti TC"/>
-              </a:defRPr>
-            </a:lvl4pPr>
-            <a:lvl5pPr algn="l">
-              <a:defRPr sz="1800" b="0">
-                <a:solidFill>
-                  <a:srgbClr val="102B40"/>
-                </a:solidFill>
-                <a:latin typeface="Heiti TC"/>
-                <a:ea typeface="Heiti TC"/>
-                <a:cs typeface="Heiti TC"/>
-              </a:defRPr>
-            </a:lvl5pPr>
-            <a:lvl6pPr algn="l">
-              <a:defRPr sz="1800" b="0">
-                <a:solidFill>
-                  <a:srgbClr val="102B40"/>
-                </a:solidFill>
-                <a:latin typeface="Heiti TC"/>
-                <a:ea typeface="Heiti TC"/>
-                <a:cs typeface="Heiti TC"/>
-              </a:defRPr>
-            </a:lvl6pPr>
-            <a:lvl7pPr algn="l">
-              <a:defRPr sz="1800" b="0">
-                <a:solidFill>
-                  <a:srgbClr val="102B40"/>
-                </a:solidFill>
-                <a:latin typeface="Heiti TC"/>
-                <a:ea typeface="Heiti TC"/>
-                <a:cs typeface="Heiti TC"/>
-              </a:defRPr>
-            </a:lvl7pPr>
-            <a:lvl8pPr algn="l">
-              <a:defRPr sz="1800" b="0">
-                <a:solidFill>
-                  <a:srgbClr val="102B40"/>
-                </a:solidFill>
-                <a:latin typeface="Heiti TC"/>
-                <a:ea typeface="Heiti TC"/>
-                <a:cs typeface="Heiti TC"/>
-              </a:defRPr>
-            </a:lvl8pPr>
-            <a:lvl9pPr algn="l">
-              <a:defRPr sz="1800" b="0">
-                <a:solidFill>
-                  <a:srgbClr val="102B40"/>
-                </a:solidFill>
-                <a:latin typeface="Heiti TC"/>
-                <a:ea typeface="Heiti TC"/>
-                <a:cs typeface="Heiti TC"/>
-              </a:defRPr>
-            </a:lvl9pPr>
-          </a:lstStyle>
-          <a:p xmlns:a="http://schemas.openxmlformats.org/drawingml/2006/main">
-            <a:pPr algn="l">
-              <a:defRPr sz="1800" b="0">
-                <a:solidFill>
-                  <a:srgbClr val="102B40"/>
-                </a:solidFill>
-                <a:latin typeface="Heiti TC"/>
-                <a:ea typeface="Heiti TC"/>
-                <a:cs typeface="Heiti TC"/>
-              </a:defRPr>
-            </a:pPr>
-            <a:r>
-              <a:rPr sz="1800" b="0">
-                <a:solidFill>
-                  <a:srgbClr val="102B40"/>
-                </a:solidFill>
-                <a:latin typeface="Heiti TC"/>
-                <a:ea typeface="Heiti TC"/>
-                <a:cs typeface="Heiti TC"/>
-              </a:rPr>
-              <a:t>优先沿段落和句子切分，以长度上限控制子块大小</a:t>
-            </a:r>
-          </a:p>
-        </p:txBody>
-      </p:sp>
-      <p:sp>
-        <p:nvSpPr>
-          <p:cNvPr id="13" name="双向量召回后，按证据相关性独立精排">
-            <a:extLst xmlns:a="http://schemas.openxmlformats.org/drawingml/2006/main">
-              <a:ext uri="{FF2B5EF4-FFF2-40B4-BE49-F238E27FC236}">
-                <a16:creationId xmlns:a16="http://schemas.microsoft.com/office/drawing/2014/main" id="{45BD11F9-D5CC-4429-BA8E-D1144FCA051D}"/>
-              </a:ext>
-            </a:extLst>
-          </p:cNvPr>
-          <p:cNvSpPr>
-            <a:spLocks xmlns:a="http://schemas.openxmlformats.org/drawingml/2006/main" noGrp="1"/>
-          </p:cNvSpPr>
-          <p:nvPr/>
-        </p:nvSpPr>
-        <p:spPr>
-          <a:xfrm xmlns:a="http://schemas.openxmlformats.org/drawingml/2006/main">
-            <a:off x="6096000" y="2628900"/>
-            <a:ext cx="5476875" cy="400050"/>
-          </a:xfrm>
-          <a:prstGeom xmlns:a="http://schemas.openxmlformats.org/drawingml/2006/main" prst="rect">
-            <a:avLst/>
-          </a:prstGeom>
-          <a:noFill xmlns:a="http://schemas.openxmlformats.org/drawingml/2006/main"/>
-          <a:ln xmlns:a="http://schemas.openxmlformats.org/drawingml/2006/main" w="0">
-            <a:noFill/>
-          </a:ln>
-        </p:spPr>
-        <p:txBody>
-          <a:bodyPr xmlns:a="http://schemas.openxmlformats.org/drawingml/2006/main" wrap="square" lIns="0" tIns="0" rIns="0" bIns="0" anchor="ctr">
-            <a:noAutofit/>
-          </a:bodyPr>
-          <a:lstStyle xmlns:a="http://schemas.openxmlformats.org/drawingml/2006/main">
-            <a:defPPr algn="l">
-              <a:defRPr sz="1725" b="0">
-                <a:solidFill>
-                  <a:srgbClr val="087F8C"/>
-                </a:solidFill>
-                <a:latin typeface="Heiti TC"/>
-                <a:ea typeface="Heiti TC"/>
-                <a:cs typeface="Heiti TC"/>
-              </a:defRPr>
-            </a:defPPr>
-            <a:lvl1pPr algn="l">
-              <a:defRPr sz="1725" b="0">
-                <a:solidFill>
-                  <a:srgbClr val="087F8C"/>
-                </a:solidFill>
-                <a:latin typeface="Heiti TC"/>
-                <a:ea typeface="Heiti TC"/>
-                <a:cs typeface="Heiti TC"/>
-              </a:defRPr>
-            </a:lvl1pPr>
-            <a:lvl2pPr algn="l">
-              <a:defRPr sz="1725" b="0">
-                <a:solidFill>
-                  <a:srgbClr val="087F8C"/>
-                </a:solidFill>
-                <a:latin typeface="Heiti TC"/>
-                <a:ea typeface="Heiti TC"/>
-                <a:cs typeface="Heiti TC"/>
-              </a:defRPr>
-            </a:lvl2pPr>
-            <a:lvl3pPr algn="l">
-              <a:defRPr sz="1725" b="0">
-                <a:solidFill>
-                  <a:srgbClr val="087F8C"/>
-                </a:solidFill>
-                <a:latin typeface="Heiti TC"/>
-                <a:ea typeface="Heiti TC"/>
-                <a:cs typeface="Heiti TC"/>
-              </a:defRPr>
-            </a:lvl3pPr>
-            <a:lvl4pPr algn="l">
-              <a:defRPr sz="1725" b="0">
-                <a:solidFill>
-                  <a:srgbClr val="087F8C"/>
-                </a:solidFill>
-                <a:latin typeface="Heiti TC"/>
-                <a:ea typeface="Heiti TC"/>
-                <a:cs typeface="Heiti TC"/>
-              </a:defRPr>
-            </a:lvl4pPr>
-            <a:lvl5pPr algn="l">
-              <a:defRPr sz="1725" b="0">
-                <a:solidFill>
-                  <a:srgbClr val="087F8C"/>
-                </a:solidFill>
-                <a:latin typeface="Heiti TC"/>
-                <a:ea typeface="Heiti TC"/>
-                <a:cs typeface="Heiti TC"/>
-              </a:defRPr>
-            </a:lvl5pPr>
-            <a:lvl6pPr algn="l">
-              <a:defRPr sz="1725" b="0">
-                <a:solidFill>
-                  <a:srgbClr val="087F8C"/>
-                </a:solidFill>
-                <a:latin typeface="Heiti TC"/>
-                <a:ea typeface="Heiti TC"/>
-                <a:cs typeface="Heiti TC"/>
-              </a:defRPr>
-            </a:lvl6pPr>
-            <a:lvl7pPr algn="l">
-              <a:defRPr sz="1725" b="0">
-                <a:solidFill>
-                  <a:srgbClr val="087F8C"/>
-                </a:solidFill>
-                <a:latin typeface="Heiti TC"/>
-                <a:ea typeface="Heiti TC"/>
-                <a:cs typeface="Heiti TC"/>
-              </a:defRPr>
-            </a:lvl7pPr>
-            <a:lvl8pPr algn="l">
-              <a:defRPr sz="1725" b="0">
-                <a:solidFill>
-                  <a:srgbClr val="087F8C"/>
-                </a:solidFill>
-                <a:latin typeface="Heiti TC"/>
-                <a:ea typeface="Heiti TC"/>
-                <a:cs typeface="Heiti TC"/>
-              </a:defRPr>
-            </a:lvl8pPr>
-            <a:lvl9pPr algn="l">
-              <a:defRPr sz="1725" b="0">
-                <a:solidFill>
-                  <a:srgbClr val="087F8C"/>
-                </a:solidFill>
-                <a:latin typeface="Heiti TC"/>
-                <a:ea typeface="Heiti TC"/>
-                <a:cs typeface="Heiti TC"/>
-              </a:defRPr>
-            </a:lvl9pPr>
-          </a:lstStyle>
-          <a:p xmlns:a="http://schemas.openxmlformats.org/drawingml/2006/main">
-            <a:pPr algn="l">
-              <a:defRPr sz="1725" b="0">
-                <a:solidFill>
-                  <a:srgbClr val="087F8C"/>
-                </a:solidFill>
-                <a:latin typeface="Heiti TC"/>
-                <a:ea typeface="Heiti TC"/>
-                <a:cs typeface="Heiti TC"/>
-              </a:defRPr>
-            </a:pPr>
-            <a:r>
-              <a:rPr sz="1725" b="0">
-                <a:solidFill>
-                  <a:srgbClr val="087F8C"/>
-                </a:solidFill>
-                <a:latin typeface="Heiti TC"/>
-                <a:ea typeface="Heiti TC"/>
-                <a:cs typeface="Heiti TC"/>
-              </a:rPr>
-              <a:t>每个子块关联唯一父块 ID</a:t>
-            </a:r>
-          </a:p>
-        </p:txBody>
-      </p:sp>
-      <p:cxnSp>
-        <p:nvCxnSpPr>
-          <p:cNvPr id="14" name="">
-            <a:extLst xmlns:a="http://schemas.openxmlformats.org/drawingml/2006/main">
-              <a:ext uri="{FF2B5EF4-FFF2-40B4-BE49-F238E27FC236}">
-                <a16:creationId xmlns:a16="http://schemas.microsoft.com/office/drawing/2014/main" id="{F50061E9-F5F0-4767-A10E-56652B4D04EE}"/>
-              </a:ext>
-            </a:extLst>
-          </p:cNvPr>
-          <p:cNvCxnSpPr/>
-          <p:nvPr/>
-        </p:nvCxnSpPr>
-        <p:spPr>
-          <a:xfrm xmlns:a="http://schemas.openxmlformats.org/drawingml/2006/main" flipH="0" flipV="0">
-            <a:off x="1333500" y="3562350"/>
-            <a:ext cx="10334625" cy="0"/>
-          </a:xfrm>
-          <a:prstGeom xmlns:a="http://schemas.openxmlformats.org/drawingml/2006/main" prst="straightConnector1">
-            <a:avLst/>
-          </a:prstGeom>
-          <a:ln xmlns:a="http://schemas.openxmlformats.org/drawingml/2006/main" w="15240">
-            <a:solidFill>
-              <a:srgbClr val="B6C8D6"/>
-            </a:solidFill>
-            <a:prstDash val="solid"/>
-            <a:tailEnd type="none" w="med" len="med"/>
-          </a:ln>
-        </p:spPr>
-      </p:cxnSp>
-      <p:sp>
-        <p:nvSpPr>
-          <p:cNvPr id="15" name="03">
-            <a:extLst xmlns:a="http://schemas.openxmlformats.org/drawingml/2006/main">
-              <a:ext uri="{FF2B5EF4-FFF2-40B4-BE49-F238E27FC236}">
-                <a16:creationId xmlns:a16="http://schemas.microsoft.com/office/drawing/2014/main" id="{9502B0ED-0B21-4DE5-B879-BF0957CC7D7D}"/>
-              </a:ext>
-            </a:extLst>
-          </p:cNvPr>
-          <p:cNvSpPr>
-            <a:spLocks xmlns:a="http://schemas.openxmlformats.org/drawingml/2006/main" noGrp="1"/>
-          </p:cNvSpPr>
-          <p:nvPr/>
-        </p:nvSpPr>
-        <p:spPr>
-          <a:xfrm xmlns:a="http://schemas.openxmlformats.org/drawingml/2006/main">
-            <a:off x="523875" y="3733800"/>
-            <a:ext cx="628650" cy="428625"/>
-          </a:xfrm>
-          <a:prstGeom xmlns:a="http://schemas.openxmlformats.org/drawingml/2006/main" prst="rect">
-            <a:avLst/>
-          </a:prstGeom>
-          <a:noFill xmlns:a="http://schemas.openxmlformats.org/drawingml/2006/main"/>
-          <a:ln xmlns:a="http://schemas.openxmlformats.org/drawingml/2006/main" w="0">
-            <a:noFill/>
-          </a:ln>
-        </p:spPr>
-        <p:txBody>
-          <a:bodyPr xmlns:a="http://schemas.openxmlformats.org/drawingml/2006/main" wrap="square" lIns="0" tIns="0" rIns="0" bIns="0" anchor="ctr">
-            <a:noAutofit/>
-          </a:bodyPr>
-          <a:lstStyle xmlns:a="http://schemas.openxmlformats.org/drawingml/2006/main">
-            <a:defPPr algn="l">
-              <a:defRPr sz="2325" b="1">
-                <a:solidFill>
-                  <a:srgbClr val="087F8C"/>
-                </a:solidFill>
-                <a:latin typeface="Heiti TC"/>
-                <a:ea typeface="Heiti TC"/>
-                <a:cs typeface="Heiti TC"/>
-              </a:defRPr>
-            </a:defPPr>
-            <a:lvl1pPr algn="l">
-              <a:defRPr sz="2325" b="1">
-                <a:solidFill>
-                  <a:srgbClr val="087F8C"/>
-                </a:solidFill>
-                <a:latin typeface="Heiti TC"/>
-                <a:ea typeface="Heiti TC"/>
-                <a:cs typeface="Heiti TC"/>
-              </a:defRPr>
-            </a:lvl1pPr>
-            <a:lvl2pPr algn="l">
-              <a:defRPr sz="2325" b="1">
-                <a:solidFill>
-                  <a:srgbClr val="087F8C"/>
-                </a:solidFill>
-                <a:latin typeface="Heiti TC"/>
-                <a:ea typeface="Heiti TC"/>
-                <a:cs typeface="Heiti TC"/>
-              </a:defRPr>
-            </a:lvl2pPr>
-            <a:lvl3pPr algn="l">
-              <a:defRPr sz="2325" b="1">
-                <a:solidFill>
-                  <a:srgbClr val="087F8C"/>
-                </a:solidFill>
-                <a:latin typeface="Heiti TC"/>
-                <a:ea typeface="Heiti TC"/>
-                <a:cs typeface="Heiti TC"/>
-              </a:defRPr>
-            </a:lvl3pPr>
-            <a:lvl4pPr algn="l">
-              <a:defRPr sz="2325" b="1">
-                <a:solidFill>
-                  <a:srgbClr val="087F8C"/>
-                </a:solidFill>
-                <a:latin typeface="Heiti TC"/>
-                <a:ea typeface="Heiti TC"/>
-                <a:cs typeface="Heiti TC"/>
-              </a:defRPr>
-            </a:lvl4pPr>
-            <a:lvl5pPr algn="l">
-              <a:defRPr sz="2325" b="1">
-                <a:solidFill>
-                  <a:srgbClr val="087F8C"/>
-                </a:solidFill>
-                <a:latin typeface="Heiti TC"/>
-                <a:ea typeface="Heiti TC"/>
-                <a:cs typeface="Heiti TC"/>
-              </a:defRPr>
-            </a:lvl5pPr>
-            <a:lvl6pPr algn="l">
-              <a:defRPr sz="2325" b="1">
-                <a:solidFill>
-                  <a:srgbClr val="087F8C"/>
-                </a:solidFill>
-                <a:latin typeface="Heiti TC"/>
-                <a:ea typeface="Heiti TC"/>
-                <a:cs typeface="Heiti TC"/>
-              </a:defRPr>
-            </a:lvl6pPr>
-            <a:lvl7pPr algn="l">
-              <a:defRPr sz="2325" b="1">
-                <a:solidFill>
-                  <a:srgbClr val="087F8C"/>
-                </a:solidFill>
-                <a:latin typeface="Heiti TC"/>
-                <a:ea typeface="Heiti TC"/>
-                <a:cs typeface="Heiti TC"/>
-              </a:defRPr>
-            </a:lvl7pPr>
-            <a:lvl8pPr algn="l">
-              <a:defRPr sz="2325" b="1">
-                <a:solidFill>
-                  <a:srgbClr val="087F8C"/>
-                </a:solidFill>
-                <a:latin typeface="Heiti TC"/>
-                <a:ea typeface="Heiti TC"/>
-                <a:cs typeface="Heiti TC"/>
-              </a:defRPr>
-            </a:lvl8pPr>
-            <a:lvl9pPr algn="l">
-              <a:defRPr sz="2325" b="1">
-                <a:solidFill>
-                  <a:srgbClr val="087F8C"/>
-                </a:solidFill>
-                <a:latin typeface="Heiti TC"/>
-                <a:ea typeface="Heiti TC"/>
-                <a:cs typeface="Heiti TC"/>
-              </a:defRPr>
-            </a:lvl9pPr>
-          </a:lstStyle>
-          <a:p xmlns:a="http://schemas.openxmlformats.org/drawingml/2006/main">
-            <a:pPr algn="l">
-              <a:defRPr sz="2325" b="1">
-                <a:solidFill>
-                  <a:srgbClr val="087F8C"/>
-                </a:solidFill>
-                <a:latin typeface="Heiti TC"/>
-                <a:ea typeface="Heiti TC"/>
-                <a:cs typeface="Heiti TC"/>
-              </a:defRPr>
-            </a:pPr>
-            <a:r>
-              <a:rPr sz="2325" b="1">
-                <a:solidFill>
-                  <a:srgbClr val="087F8C"/>
-                </a:solidFill>
-                <a:latin typeface="Heiti TC"/>
-                <a:ea typeface="Heiti TC"/>
-                <a:cs typeface="Heiti TC"/>
-              </a:rPr>
-              <a:t>03</a:t>
-            </a:r>
-          </a:p>
-        </p:txBody>
-      </p:sp>
-      <p:sp>
-        <p:nvSpPr>
-          <p:cNvPr id="16" name="参数关系查询有确定结果">
-            <a:extLst xmlns:a="http://schemas.openxmlformats.org/drawingml/2006/main">
-              <a:ext uri="{FF2B5EF4-FFF2-40B4-BE49-F238E27FC236}">
-                <a16:creationId xmlns:a16="http://schemas.microsoft.com/office/drawing/2014/main" id="{8FE8F357-C00A-41F6-B71F-AF94838D19BB}"/>
-              </a:ext>
-            </a:extLst>
-          </p:cNvPr>
-          <p:cNvSpPr>
-            <a:spLocks xmlns:a="http://schemas.openxmlformats.org/drawingml/2006/main" noGrp="1"/>
-          </p:cNvSpPr>
-          <p:nvPr/>
-        </p:nvSpPr>
-        <p:spPr>
-          <a:xfrm xmlns:a="http://schemas.openxmlformats.org/drawingml/2006/main">
-            <a:off x="1333500" y="3733800"/>
-            <a:ext cx="4191000" cy="381000"/>
-          </a:xfrm>
-          <a:prstGeom xmlns:a="http://schemas.openxmlformats.org/drawingml/2006/main" prst="rect">
-            <a:avLst/>
-          </a:prstGeom>
-          <a:noFill xmlns:a="http://schemas.openxmlformats.org/drawingml/2006/main"/>
-          <a:ln xmlns:a="http://schemas.openxmlformats.org/drawingml/2006/main" w="0">
-            <a:noFill/>
-          </a:ln>
-        </p:spPr>
-        <p:txBody>
-          <a:bodyPr xmlns:a="http://schemas.openxmlformats.org/drawingml/2006/main" wrap="square" lIns="0" tIns="0" rIns="0" bIns="0" anchor="ctr">
-            <a:noAutofit/>
-          </a:bodyPr>
-          <a:lstStyle xmlns:a="http://schemas.openxmlformats.org/drawingml/2006/main">
-            <a:defPPr algn="l">
-              <a:defRPr sz="2025" b="1">
-                <a:solidFill>
-                  <a:srgbClr val="102B40"/>
-                </a:solidFill>
-                <a:latin typeface="Heiti TC"/>
-                <a:ea typeface="Heiti TC"/>
-                <a:cs typeface="Heiti TC"/>
-              </a:defRPr>
-            </a:defPPr>
-            <a:lvl1pPr algn="l">
-              <a:defRPr sz="2025" b="1">
-                <a:solidFill>
-                  <a:srgbClr val="102B40"/>
-                </a:solidFill>
-                <a:latin typeface="Heiti TC"/>
-                <a:ea typeface="Heiti TC"/>
-                <a:cs typeface="Heiti TC"/>
-              </a:defRPr>
-            </a:lvl1pPr>
-            <a:lvl2pPr algn="l">
-              <a:defRPr sz="2025" b="1">
-                <a:solidFill>
-                  <a:srgbClr val="102B40"/>
-                </a:solidFill>
-                <a:latin typeface="Heiti TC"/>
-                <a:ea typeface="Heiti TC"/>
-                <a:cs typeface="Heiti TC"/>
-              </a:defRPr>
-            </a:lvl2pPr>
-            <a:lvl3pPr algn="l">
-              <a:defRPr sz="2025" b="1">
-                <a:solidFill>
-                  <a:srgbClr val="102B40"/>
-                </a:solidFill>
-                <a:latin typeface="Heiti TC"/>
-                <a:ea typeface="Heiti TC"/>
-                <a:cs typeface="Heiti TC"/>
-              </a:defRPr>
-            </a:lvl3pPr>
-            <a:lvl4pPr algn="l">
-              <a:defRPr sz="2025" b="1">
-                <a:solidFill>
-                  <a:srgbClr val="102B40"/>
-                </a:solidFill>
-                <a:latin typeface="Heiti TC"/>
-                <a:ea typeface="Heiti TC"/>
-                <a:cs typeface="Heiti TC"/>
-              </a:defRPr>
-            </a:lvl4pPr>
-            <a:lvl5pPr algn="l">
-              <a:defRPr sz="2025" b="1">
-                <a:solidFill>
-                  <a:srgbClr val="102B40"/>
-                </a:solidFill>
-                <a:latin typeface="Heiti TC"/>
-                <a:ea typeface="Heiti TC"/>
-                <a:cs typeface="Heiti TC"/>
-              </a:defRPr>
-            </a:lvl5pPr>
-            <a:lvl6pPr algn="l">
-              <a:defRPr sz="2025" b="1">
-                <a:solidFill>
-                  <a:srgbClr val="102B40"/>
-                </a:solidFill>
-                <a:latin typeface="Heiti TC"/>
-                <a:ea typeface="Heiti TC"/>
-                <a:cs typeface="Heiti TC"/>
-              </a:defRPr>
-            </a:lvl6pPr>
-            <a:lvl7pPr algn="l">
-              <a:defRPr sz="2025" b="1">
-                <a:solidFill>
-                  <a:srgbClr val="102B40"/>
-                </a:solidFill>
-                <a:latin typeface="Heiti TC"/>
-                <a:ea typeface="Heiti TC"/>
-                <a:cs typeface="Heiti TC"/>
-              </a:defRPr>
-            </a:lvl7pPr>
-            <a:lvl8pPr algn="l">
-              <a:defRPr sz="2025" b="1">
-                <a:solidFill>
-                  <a:srgbClr val="102B40"/>
-                </a:solidFill>
-                <a:latin typeface="Heiti TC"/>
-                <a:ea typeface="Heiti TC"/>
-                <a:cs typeface="Heiti TC"/>
-              </a:defRPr>
-            </a:lvl8pPr>
-            <a:lvl9pPr algn="l">
-              <a:defRPr sz="2025" b="1">
-                <a:solidFill>
-                  <a:srgbClr val="102B40"/>
-                </a:solidFill>
-                <a:latin typeface="Heiti TC"/>
-                <a:ea typeface="Heiti TC"/>
-                <a:cs typeface="Heiti TC"/>
-              </a:defRPr>
-            </a:lvl9pPr>
-          </a:lstStyle>
-          <a:p xmlns:a="http://schemas.openxmlformats.org/drawingml/2006/main">
-            <a:pPr algn="l">
-              <a:defRPr sz="2025" b="1">
-                <a:solidFill>
-                  <a:srgbClr val="102B40"/>
-                </a:solidFill>
-                <a:latin typeface="Heiti TC"/>
-                <a:ea typeface="Heiti TC"/>
-                <a:cs typeface="Heiti TC"/>
-              </a:defRPr>
-            </a:pPr>
-            <a:r>
-              <a:rPr sz="2025" b="1">
-                <a:solidFill>
-                  <a:srgbClr val="102B40"/>
-                </a:solidFill>
-                <a:latin typeface="Heiti TC"/>
-                <a:ea typeface="Heiti TC"/>
-                <a:cs typeface="Heiti TC"/>
-              </a:rPr>
-              <a:t>父块正文存 PostgreSQL</a:t>
-            </a:r>
-          </a:p>
-        </p:txBody>
-      </p:sp>
-      <p:sp>
-        <p:nvSpPr>
-          <p:cNvPr id="17" name="Neo4j 支持型号比较、共同参数与多条件筛选">
-            <a:extLst xmlns:a="http://schemas.openxmlformats.org/drawingml/2006/main">
-              <a:ext uri="{FF2B5EF4-FFF2-40B4-BE49-F238E27FC236}">
-                <a16:creationId xmlns:a16="http://schemas.microsoft.com/office/drawing/2014/main" id="{5521D735-3D85-4D9F-9B9B-2B2D5EF4E7B8}"/>
-              </a:ext>
-            </a:extLst>
-          </p:cNvPr>
-          <p:cNvSpPr>
-            <a:spLocks xmlns:a="http://schemas.openxmlformats.org/drawingml/2006/main" noGrp="1"/>
-          </p:cNvSpPr>
-          <p:nvPr/>
-        </p:nvSpPr>
-        <p:spPr>
-          <a:xfrm xmlns:a="http://schemas.openxmlformats.org/drawingml/2006/main">
-            <a:off x="1333500" y="4181475"/>
-            <a:ext cx="10287000" cy="323850"/>
-          </a:xfrm>
-          <a:prstGeom xmlns:a="http://schemas.openxmlformats.org/drawingml/2006/main" prst="rect">
-            <a:avLst/>
-          </a:prstGeom>
-          <a:noFill xmlns:a="http://schemas.openxmlformats.org/drawingml/2006/main"/>
-          <a:ln xmlns:a="http://schemas.openxmlformats.org/drawingml/2006/main" w="0">
-            <a:noFill/>
-          </a:ln>
-        </p:spPr>
-        <p:txBody>
-          <a:bodyPr xmlns:a="http://schemas.openxmlformats.org/drawingml/2006/main" wrap="square" lIns="0" tIns="0" rIns="0" bIns="0" anchor="ctr">
-            <a:noAutofit/>
-          </a:bodyPr>
-          <a:lstStyle xmlns:a="http://schemas.openxmlformats.org/drawingml/2006/main">
-            <a:defPPr algn="l">
-              <a:defRPr sz="1800" b="0">
-                <a:solidFill>
-                  <a:srgbClr val="102B40"/>
-                </a:solidFill>
-                <a:latin typeface="Heiti TC"/>
-                <a:ea typeface="Heiti TC"/>
-                <a:cs typeface="Heiti TC"/>
-              </a:defRPr>
-            </a:defPPr>
-            <a:lvl1pPr algn="l">
-              <a:defRPr sz="1800" b="0">
-                <a:solidFill>
-                  <a:srgbClr val="102B40"/>
-                </a:solidFill>
-                <a:latin typeface="Heiti TC"/>
-                <a:ea typeface="Heiti TC"/>
-                <a:cs typeface="Heiti TC"/>
-              </a:defRPr>
-            </a:lvl1pPr>
-            <a:lvl2pPr algn="l">
-              <a:defRPr sz="1800" b="0">
-                <a:solidFill>
-                  <a:srgbClr val="102B40"/>
-                </a:solidFill>
-                <a:latin typeface="Heiti TC"/>
-                <a:ea typeface="Heiti TC"/>
-                <a:cs typeface="Heiti TC"/>
-              </a:defRPr>
-            </a:lvl2pPr>
-            <a:lvl3pPr algn="l">
-              <a:defRPr sz="1800" b="0">
-                <a:solidFill>
-                  <a:srgbClr val="102B40"/>
-                </a:solidFill>
-                <a:latin typeface="Heiti TC"/>
-                <a:ea typeface="Heiti TC"/>
-                <a:cs typeface="Heiti TC"/>
-              </a:defRPr>
-            </a:lvl3pPr>
-            <a:lvl4pPr algn="l">
-              <a:defRPr sz="1800" b="0">
-                <a:solidFill>
-                  <a:srgbClr val="102B40"/>
-                </a:solidFill>
-                <a:latin typeface="Heiti TC"/>
-                <a:ea typeface="Heiti TC"/>
-                <a:cs typeface="Heiti TC"/>
-              </a:defRPr>
-            </a:lvl4pPr>
-            <a:lvl5pPr algn="l">
-              <a:defRPr sz="1800" b="0">
-                <a:solidFill>
-                  <a:srgbClr val="102B40"/>
-                </a:solidFill>
-                <a:latin typeface="Heiti TC"/>
-                <a:ea typeface="Heiti TC"/>
-                <a:cs typeface="Heiti TC"/>
-              </a:defRPr>
-            </a:lvl5pPr>
-            <a:lvl6pPr algn="l">
-              <a:defRPr sz="1800" b="0">
-                <a:solidFill>
-                  <a:srgbClr val="102B40"/>
-                </a:solidFill>
-                <a:latin typeface="Heiti TC"/>
-                <a:ea typeface="Heiti TC"/>
-                <a:cs typeface="Heiti TC"/>
-              </a:defRPr>
-            </a:lvl6pPr>
-            <a:lvl7pPr algn="l">
-              <a:defRPr sz="1800" b="0">
-                <a:solidFill>
-                  <a:srgbClr val="102B40"/>
-                </a:solidFill>
-                <a:latin typeface="Heiti TC"/>
-                <a:ea typeface="Heiti TC"/>
-                <a:cs typeface="Heiti TC"/>
-              </a:defRPr>
-            </a:lvl7pPr>
-            <a:lvl8pPr algn="l">
-              <a:defRPr sz="1800" b="0">
-                <a:solidFill>
-                  <a:srgbClr val="102B40"/>
-                </a:solidFill>
-                <a:latin typeface="Heiti TC"/>
-                <a:ea typeface="Heiti TC"/>
-                <a:cs typeface="Heiti TC"/>
-              </a:defRPr>
-            </a:lvl8pPr>
-            <a:lvl9pPr algn="l">
-              <a:defRPr sz="1800" b="0">
-                <a:solidFill>
-                  <a:srgbClr val="102B40"/>
-                </a:solidFill>
-                <a:latin typeface="Heiti TC"/>
-                <a:ea typeface="Heiti TC"/>
-                <a:cs typeface="Heiti TC"/>
-              </a:defRPr>
-            </a:lvl9pPr>
-          </a:lstStyle>
-          <a:p xmlns:a="http://schemas.openxmlformats.org/drawingml/2006/main">
-            <a:pPr algn="l">
-              <a:defRPr sz="1800" b="0">
-                <a:solidFill>
-                  <a:srgbClr val="102B40"/>
-                </a:solidFill>
-                <a:latin typeface="Heiti TC"/>
-                <a:ea typeface="Heiti TC"/>
-                <a:cs typeface="Heiti TC"/>
-              </a:defRPr>
-            </a:pPr>
-            <a:r>
-              <a:rPr sz="1800" b="0">
-                <a:solidFill>
-                  <a:srgbClr val="102B40"/>
-                </a:solidFill>
-                <a:latin typeface="Heiti TC"/>
-                <a:ea typeface="Heiti TC"/>
-                <a:cs typeface="Heiti TC"/>
-              </a:rPr>
-              <a:t>保存父块正文、父块 ID、文档 ID、版本及适用范围</a:t>
-            </a:r>
-          </a:p>
-        </p:txBody>
-      </p:sp>
-      <p:sp>
-        <p:nvSpPr>
-          <p:cNvPr id="18" name="固定 Cypher 查询，程序计算差值与筛选结果">
-            <a:extLst xmlns:a="http://schemas.openxmlformats.org/drawingml/2006/main">
-              <a:ext uri="{FF2B5EF4-FFF2-40B4-BE49-F238E27FC236}">
-                <a16:creationId xmlns:a16="http://schemas.microsoft.com/office/drawing/2014/main" id="{05B265A6-06F2-46B6-B0C2-D3A2C2221F0F}"/>
-              </a:ext>
-            </a:extLst>
-          </p:cNvPr>
-          <p:cNvSpPr>
-            <a:spLocks xmlns:a="http://schemas.openxmlformats.org/drawingml/2006/main" noGrp="1"/>
-          </p:cNvSpPr>
-          <p:nvPr/>
-        </p:nvSpPr>
-        <p:spPr>
-          <a:xfrm xmlns:a="http://schemas.openxmlformats.org/drawingml/2006/main">
-            <a:off x="6096000" y="3733800"/>
-            <a:ext cx="5476875" cy="400050"/>
-          </a:xfrm>
-          <a:prstGeom xmlns:a="http://schemas.openxmlformats.org/drawingml/2006/main" prst="rect">
-            <a:avLst/>
-          </a:prstGeom>
-          <a:noFill xmlns:a="http://schemas.openxmlformats.org/drawingml/2006/main"/>
-          <a:ln xmlns:a="http://schemas.openxmlformats.org/drawingml/2006/main" w="0">
-            <a:noFill/>
-          </a:ln>
-        </p:spPr>
-        <p:txBody>
-          <a:bodyPr xmlns:a="http://schemas.openxmlformats.org/drawingml/2006/main" wrap="square" lIns="0" tIns="0" rIns="0" bIns="0" anchor="ctr">
-            <a:noAutofit/>
-          </a:bodyPr>
-          <a:lstStyle xmlns:a="http://schemas.openxmlformats.org/drawingml/2006/main">
-            <a:defPPr algn="l">
-              <a:defRPr sz="1725" b="0">
-                <a:solidFill>
-                  <a:srgbClr val="087F8C"/>
-                </a:solidFill>
-                <a:latin typeface="Heiti TC"/>
-                <a:ea typeface="Heiti TC"/>
-                <a:cs typeface="Heiti TC"/>
-              </a:defRPr>
-            </a:defPPr>
-            <a:lvl1pPr algn="l">
-              <a:defRPr sz="1725" b="0">
-                <a:solidFill>
-                  <a:srgbClr val="087F8C"/>
-                </a:solidFill>
-                <a:latin typeface="Heiti TC"/>
-                <a:ea typeface="Heiti TC"/>
-                <a:cs typeface="Heiti TC"/>
-              </a:defRPr>
-            </a:lvl1pPr>
-            <a:lvl2pPr algn="l">
-              <a:defRPr sz="1725" b="0">
-                <a:solidFill>
-                  <a:srgbClr val="087F8C"/>
-                </a:solidFill>
-                <a:latin typeface="Heiti TC"/>
-                <a:ea typeface="Heiti TC"/>
-                <a:cs typeface="Heiti TC"/>
-              </a:defRPr>
-            </a:lvl2pPr>
-            <a:lvl3pPr algn="l">
-              <a:defRPr sz="1725" b="0">
-                <a:solidFill>
-                  <a:srgbClr val="087F8C"/>
-                </a:solidFill>
-                <a:latin typeface="Heiti TC"/>
-                <a:ea typeface="Heiti TC"/>
-                <a:cs typeface="Heiti TC"/>
-              </a:defRPr>
-            </a:lvl3pPr>
-            <a:lvl4pPr algn="l">
-              <a:defRPr sz="1725" b="0">
-                <a:solidFill>
-                  <a:srgbClr val="087F8C"/>
-                </a:solidFill>
-                <a:latin typeface="Heiti TC"/>
-                <a:ea typeface="Heiti TC"/>
-                <a:cs typeface="Heiti TC"/>
-              </a:defRPr>
-            </a:lvl4pPr>
-            <a:lvl5pPr algn="l">
-              <a:defRPr sz="1725" b="0">
-                <a:solidFill>
-                  <a:srgbClr val="087F8C"/>
-                </a:solidFill>
-                <a:latin typeface="Heiti TC"/>
-                <a:ea typeface="Heiti TC"/>
-                <a:cs typeface="Heiti TC"/>
-              </a:defRPr>
-            </a:lvl5pPr>
-            <a:lvl6pPr algn="l">
-              <a:defRPr sz="1725" b="0">
-                <a:solidFill>
-                  <a:srgbClr val="087F8C"/>
-                </a:solidFill>
-                <a:latin typeface="Heiti TC"/>
-                <a:ea typeface="Heiti TC"/>
-                <a:cs typeface="Heiti TC"/>
-              </a:defRPr>
-            </a:lvl6pPr>
-            <a:lvl7pPr algn="l">
-              <a:defRPr sz="1725" b="0">
-                <a:solidFill>
-                  <a:srgbClr val="087F8C"/>
-                </a:solidFill>
-                <a:latin typeface="Heiti TC"/>
-                <a:ea typeface="Heiti TC"/>
-                <a:cs typeface="Heiti TC"/>
-              </a:defRPr>
-            </a:lvl7pPr>
-            <a:lvl8pPr algn="l">
-              <a:defRPr sz="1725" b="0">
-                <a:solidFill>
-                  <a:srgbClr val="087F8C"/>
-                </a:solidFill>
-                <a:latin typeface="Heiti TC"/>
-                <a:ea typeface="Heiti TC"/>
-                <a:cs typeface="Heiti TC"/>
-              </a:defRPr>
-            </a:lvl8pPr>
-            <a:lvl9pPr algn="l">
-              <a:defRPr sz="1725" b="0">
-                <a:solidFill>
-                  <a:srgbClr val="087F8C"/>
-                </a:solidFill>
-                <a:latin typeface="Heiti TC"/>
-                <a:ea typeface="Heiti TC"/>
-                <a:cs typeface="Heiti TC"/>
-              </a:defRPr>
-            </a:lvl9pPr>
-          </a:lstStyle>
-          <a:p xmlns:a="http://schemas.openxmlformats.org/drawingml/2006/main">
-            <a:pPr algn="l">
-              <a:defRPr sz="1725" b="0">
-                <a:solidFill>
-                  <a:srgbClr val="087F8C"/>
-                </a:solidFill>
-                <a:latin typeface="Heiti TC"/>
-                <a:ea typeface="Heiti TC"/>
-                <a:cs typeface="Heiti TC"/>
-              </a:defRPr>
-            </a:pPr>
-            <a:r>
-              <a:rPr sz="1725" b="0">
-                <a:solidFill>
-                  <a:srgbClr val="087F8C"/>
-                </a:solidFill>
-                <a:latin typeface="Heiti TC"/>
-                <a:ea typeface="Heiti TC"/>
-                <a:cs typeface="Heiti TC"/>
-              </a:rPr>
-              <a:t>按父块 ID 与版本批量回查</a:t>
-            </a:r>
-          </a:p>
-        </p:txBody>
-      </p:sp>
-      <p:cxnSp>
-        <p:nvCxnSpPr>
-          <p:cNvPr id="19" name="">
-            <a:extLst xmlns:a="http://schemas.openxmlformats.org/drawingml/2006/main">
-              <a:ext uri="{FF2B5EF4-FFF2-40B4-BE49-F238E27FC236}">
-                <a16:creationId xmlns:a16="http://schemas.microsoft.com/office/drawing/2014/main" id="{6E345013-B3E3-47F8-BD39-BD648E56961C}"/>
-              </a:ext>
-            </a:extLst>
-          </p:cNvPr>
-          <p:cNvCxnSpPr/>
-          <p:nvPr/>
-        </p:nvCxnSpPr>
-        <p:spPr>
-          <a:xfrm xmlns:a="http://schemas.openxmlformats.org/drawingml/2006/main" flipH="0" flipV="0">
-            <a:off x="1333500" y="4667250"/>
-            <a:ext cx="10334625" cy="0"/>
-          </a:xfrm>
-          <a:prstGeom xmlns:a="http://schemas.openxmlformats.org/drawingml/2006/main" prst="straightConnector1">
-            <a:avLst/>
-          </a:prstGeom>
-          <a:ln xmlns:a="http://schemas.openxmlformats.org/drawingml/2006/main" w="15240">
-            <a:solidFill>
-              <a:srgbClr val="B6C8D6"/>
-            </a:solidFill>
-            <a:prstDash val="solid"/>
-            <a:tailEnd type="none" w="med" len="med"/>
-          </a:ln>
-        </p:spPr>
-      </p:cxnSp>
-      <p:sp>
-        <p:nvSpPr>
-          <p:cNvPr id="20" name="04">
-            <a:extLst xmlns:a="http://schemas.openxmlformats.org/drawingml/2006/main">
-              <a:ext uri="{FF2B5EF4-FFF2-40B4-BE49-F238E27FC236}">
-                <a16:creationId xmlns:a16="http://schemas.microsoft.com/office/drawing/2014/main" id="{DB484E4C-C365-4ACD-A25F-6CE5BFBABFD6}"/>
-              </a:ext>
-            </a:extLst>
-          </p:cNvPr>
-          <p:cNvSpPr>
-            <a:spLocks xmlns:a="http://schemas.openxmlformats.org/drawingml/2006/main" noGrp="1"/>
-          </p:cNvSpPr>
-          <p:nvPr/>
-        </p:nvSpPr>
-        <p:spPr>
-          <a:xfrm xmlns:a="http://schemas.openxmlformats.org/drawingml/2006/main">
-            <a:off x="523875" y="4838700"/>
-            <a:ext cx="628650" cy="428625"/>
-          </a:xfrm>
-          <a:prstGeom xmlns:a="http://schemas.openxmlformats.org/drawingml/2006/main" prst="rect">
-            <a:avLst/>
-          </a:prstGeom>
-          <a:noFill xmlns:a="http://schemas.openxmlformats.org/drawingml/2006/main"/>
-          <a:ln xmlns:a="http://schemas.openxmlformats.org/drawingml/2006/main" w="0">
-            <a:noFill/>
-          </a:ln>
-        </p:spPr>
-        <p:txBody>
-          <a:bodyPr xmlns:a="http://schemas.openxmlformats.org/drawingml/2006/main" wrap="square" lIns="0" tIns="0" rIns="0" bIns="0" anchor="ctr">
-            <a:noAutofit/>
-          </a:bodyPr>
-          <a:lstStyle xmlns:a="http://schemas.openxmlformats.org/drawingml/2006/main">
-            <a:defPPr algn="l">
-              <a:defRPr sz="2325" b="1">
-                <a:solidFill>
-                  <a:srgbClr val="087F8C"/>
-                </a:solidFill>
-                <a:latin typeface="Heiti TC"/>
-                <a:ea typeface="Heiti TC"/>
-                <a:cs typeface="Heiti TC"/>
-              </a:defRPr>
-            </a:defPPr>
-            <a:lvl1pPr algn="l">
-              <a:defRPr sz="2325" b="1">
-                <a:solidFill>
-                  <a:srgbClr val="087F8C"/>
-                </a:solidFill>
-                <a:latin typeface="Heiti TC"/>
-                <a:ea typeface="Heiti TC"/>
-                <a:cs typeface="Heiti TC"/>
-              </a:defRPr>
-            </a:lvl1pPr>
-            <a:lvl2pPr algn="l">
-              <a:defRPr sz="2325" b="1">
-                <a:solidFill>
-                  <a:srgbClr val="087F8C"/>
-                </a:solidFill>
-                <a:latin typeface="Heiti TC"/>
-                <a:ea typeface="Heiti TC"/>
-                <a:cs typeface="Heiti TC"/>
-              </a:defRPr>
-            </a:lvl2pPr>
-            <a:lvl3pPr algn="l">
-              <a:defRPr sz="2325" b="1">
-                <a:solidFill>
-                  <a:srgbClr val="087F8C"/>
-                </a:solidFill>
-                <a:latin typeface="Heiti TC"/>
-                <a:ea typeface="Heiti TC"/>
-                <a:cs typeface="Heiti TC"/>
-              </a:defRPr>
-            </a:lvl3pPr>
-            <a:lvl4pPr algn="l">
-              <a:defRPr sz="2325" b="1">
-                <a:solidFill>
-                  <a:srgbClr val="087F8C"/>
-                </a:solidFill>
-                <a:latin typeface="Heiti TC"/>
-                <a:ea typeface="Heiti TC"/>
-                <a:cs typeface="Heiti TC"/>
-              </a:defRPr>
-            </a:lvl4pPr>
-            <a:lvl5pPr algn="l">
-              <a:defRPr sz="2325" b="1">
-                <a:solidFill>
-                  <a:srgbClr val="087F8C"/>
-                </a:solidFill>
-                <a:latin typeface="Heiti TC"/>
-                <a:ea typeface="Heiti TC"/>
-                <a:cs typeface="Heiti TC"/>
-              </a:defRPr>
-            </a:lvl5pPr>
-            <a:lvl6pPr algn="l">
-              <a:defRPr sz="2325" b="1">
-                <a:solidFill>
-                  <a:srgbClr val="087F8C"/>
-                </a:solidFill>
-                <a:latin typeface="Heiti TC"/>
-                <a:ea typeface="Heiti TC"/>
-                <a:cs typeface="Heiti TC"/>
-              </a:defRPr>
-            </a:lvl6pPr>
-            <a:lvl7pPr algn="l">
-              <a:defRPr sz="2325" b="1">
-                <a:solidFill>
-                  <a:srgbClr val="087F8C"/>
-                </a:solidFill>
-                <a:latin typeface="Heiti TC"/>
-                <a:ea typeface="Heiti TC"/>
-                <a:cs typeface="Heiti TC"/>
-              </a:defRPr>
-            </a:lvl7pPr>
-            <a:lvl8pPr algn="l">
-              <a:defRPr sz="2325" b="1">
-                <a:solidFill>
-                  <a:srgbClr val="087F8C"/>
-                </a:solidFill>
-                <a:latin typeface="Heiti TC"/>
-                <a:ea typeface="Heiti TC"/>
-                <a:cs typeface="Heiti TC"/>
-              </a:defRPr>
-            </a:lvl8pPr>
-            <a:lvl9pPr algn="l">
-              <a:defRPr sz="2325" b="1">
-                <a:solidFill>
-                  <a:srgbClr val="087F8C"/>
-                </a:solidFill>
-                <a:latin typeface="Heiti TC"/>
-                <a:ea typeface="Heiti TC"/>
-                <a:cs typeface="Heiti TC"/>
-              </a:defRPr>
-            </a:lvl9pPr>
-          </a:lstStyle>
-          <a:p xmlns:a="http://schemas.openxmlformats.org/drawingml/2006/main">
-            <a:pPr algn="l">
-              <a:defRPr sz="2325" b="1">
-                <a:solidFill>
-                  <a:srgbClr val="087F8C"/>
-                </a:solidFill>
-                <a:latin typeface="Heiti TC"/>
-                <a:ea typeface="Heiti TC"/>
-                <a:cs typeface="Heiti TC"/>
-              </a:defRPr>
-            </a:pPr>
-            <a:r>
-              <a:rPr sz="2325" b="1">
-                <a:solidFill>
-                  <a:srgbClr val="087F8C"/>
-                </a:solidFill>
-                <a:latin typeface="Heiti TC"/>
-                <a:ea typeface="Heiti TC"/>
-                <a:cs typeface="Heiti TC"/>
-              </a:rPr>
-              <a:t>04</a:t>
-            </a:r>
-          </a:p>
-        </p:txBody>
-      </p:sp>
-      <p:sp>
-        <p:nvSpPr>
-          <p:cNvPr id="21" name="售后确认与重复提交保护">
-            <a:extLst xmlns:a="http://schemas.openxmlformats.org/drawingml/2006/main">
-              <a:ext uri="{FF2B5EF4-FFF2-40B4-BE49-F238E27FC236}">
-                <a16:creationId xmlns:a16="http://schemas.microsoft.com/office/drawing/2014/main" id="{C2EE778C-0F30-4F0A-9150-80BBFFFD672D}"/>
-              </a:ext>
-            </a:extLst>
-          </p:cNvPr>
-          <p:cNvSpPr>
-            <a:spLocks xmlns:a="http://schemas.openxmlformats.org/drawingml/2006/main" noGrp="1"/>
-          </p:cNvSpPr>
-          <p:nvPr/>
-        </p:nvSpPr>
-        <p:spPr>
-          <a:xfrm xmlns:a="http://schemas.openxmlformats.org/drawingml/2006/main">
-            <a:off x="1333500" y="4838700"/>
-            <a:ext cx="4191000" cy="381000"/>
-          </a:xfrm>
-          <a:prstGeom xmlns:a="http://schemas.openxmlformats.org/drawingml/2006/main" prst="rect">
-            <a:avLst/>
-          </a:prstGeom>
-          <a:noFill xmlns:a="http://schemas.openxmlformats.org/drawingml/2006/main"/>
-          <a:ln xmlns:a="http://schemas.openxmlformats.org/drawingml/2006/main" w="0">
-            <a:noFill/>
-          </a:ln>
-        </p:spPr>
-        <p:txBody>
-          <a:bodyPr xmlns:a="http://schemas.openxmlformats.org/drawingml/2006/main" wrap="square" lIns="0" tIns="0" rIns="0" bIns="0" anchor="ctr">
-            <a:noAutofit/>
-          </a:bodyPr>
-          <a:lstStyle xmlns:a="http://schemas.openxmlformats.org/drawingml/2006/main">
-            <a:defPPr algn="l">
-              <a:defRPr sz="2025" b="1">
-                <a:solidFill>
-                  <a:srgbClr val="102B40"/>
-                </a:solidFill>
-                <a:latin typeface="Heiti TC"/>
-                <a:ea typeface="Heiti TC"/>
-                <a:cs typeface="Heiti TC"/>
-              </a:defRPr>
-            </a:defPPr>
-            <a:lvl1pPr algn="l">
-              <a:defRPr sz="2025" b="1">
-                <a:solidFill>
-                  <a:srgbClr val="102B40"/>
-                </a:solidFill>
-                <a:latin typeface="Heiti TC"/>
-                <a:ea typeface="Heiti TC"/>
-                <a:cs typeface="Heiti TC"/>
-              </a:defRPr>
-            </a:lvl1pPr>
-            <a:lvl2pPr algn="l">
-              <a:defRPr sz="2025" b="1">
-                <a:solidFill>
-                  <a:srgbClr val="102B40"/>
-                </a:solidFill>
-                <a:latin typeface="Heiti TC"/>
-                <a:ea typeface="Heiti TC"/>
-                <a:cs typeface="Heiti TC"/>
-              </a:defRPr>
-            </a:lvl2pPr>
-            <a:lvl3pPr algn="l">
-              <a:defRPr sz="2025" b="1">
-                <a:solidFill>
-                  <a:srgbClr val="102B40"/>
-                </a:solidFill>
-                <a:latin typeface="Heiti TC"/>
-                <a:ea typeface="Heiti TC"/>
-                <a:cs typeface="Heiti TC"/>
-              </a:defRPr>
-            </a:lvl3pPr>
-            <a:lvl4pPr algn="l">
-              <a:defRPr sz="2025" b="1">
-                <a:solidFill>
-                  <a:srgbClr val="102B40"/>
-                </a:solidFill>
-                <a:latin typeface="Heiti TC"/>
-                <a:ea typeface="Heiti TC"/>
-                <a:cs typeface="Heiti TC"/>
-              </a:defRPr>
-            </a:lvl4pPr>
-            <a:lvl5pPr algn="l">
-              <a:defRPr sz="2025" b="1">
-                <a:solidFill>
-                  <a:srgbClr val="102B40"/>
-                </a:solidFill>
-                <a:latin typeface="Heiti TC"/>
-                <a:ea typeface="Heiti TC"/>
-                <a:cs typeface="Heiti TC"/>
-              </a:defRPr>
-            </a:lvl5pPr>
-            <a:lvl6pPr algn="l">
-              <a:defRPr sz="2025" b="1">
-                <a:solidFill>
-                  <a:srgbClr val="102B40"/>
-                </a:solidFill>
-                <a:latin typeface="Heiti TC"/>
-                <a:ea typeface="Heiti TC"/>
-                <a:cs typeface="Heiti TC"/>
-              </a:defRPr>
-            </a:lvl6pPr>
-            <a:lvl7pPr algn="l">
-              <a:defRPr sz="2025" b="1">
-                <a:solidFill>
-                  <a:srgbClr val="102B40"/>
-                </a:solidFill>
-                <a:latin typeface="Heiti TC"/>
-                <a:ea typeface="Heiti TC"/>
-                <a:cs typeface="Heiti TC"/>
-              </a:defRPr>
-            </a:lvl7pPr>
-            <a:lvl8pPr algn="l">
-              <a:defRPr sz="2025" b="1">
-                <a:solidFill>
-                  <a:srgbClr val="102B40"/>
-                </a:solidFill>
-                <a:latin typeface="Heiti TC"/>
-                <a:ea typeface="Heiti TC"/>
-                <a:cs typeface="Heiti TC"/>
-              </a:defRPr>
-            </a:lvl8pPr>
-            <a:lvl9pPr algn="l">
-              <a:defRPr sz="2025" b="1">
-                <a:solidFill>
-                  <a:srgbClr val="102B40"/>
-                </a:solidFill>
-                <a:latin typeface="Heiti TC"/>
-                <a:ea typeface="Heiti TC"/>
-                <a:cs typeface="Heiti TC"/>
-              </a:defRPr>
-            </a:lvl9pPr>
-          </a:lstStyle>
-          <a:p xmlns:a="http://schemas.openxmlformats.org/drawingml/2006/main">
-            <a:pPr algn="l">
-              <a:defRPr sz="2025" b="1">
-                <a:solidFill>
-                  <a:srgbClr val="102B40"/>
-                </a:solidFill>
-                <a:latin typeface="Heiti TC"/>
-                <a:ea typeface="Heiti TC"/>
-                <a:cs typeface="Heiti TC"/>
-              </a:defRPr>
-            </a:pPr>
-            <a:r>
-              <a:rPr sz="2025" b="1">
-                <a:solidFill>
-                  <a:srgbClr val="102B40"/>
-                </a:solidFill>
-                <a:latin typeface="Heiti TC"/>
-                <a:ea typeface="Heiti TC"/>
-                <a:cs typeface="Heiti TC"/>
-              </a:rPr>
-              <a:t>子块索引存 Milvus</a:t>
-            </a:r>
-          </a:p>
-        </p:txBody>
-      </p:sp>
-      <p:sp>
-        <p:nvSpPr>
-          <p:cNvPr id="22" name="核对本人订单、商品和动作，明确确认后再创建申请">
-            <a:extLst xmlns:a="http://schemas.openxmlformats.org/drawingml/2006/main">
-              <a:ext uri="{FF2B5EF4-FFF2-40B4-BE49-F238E27FC236}">
-                <a16:creationId xmlns:a16="http://schemas.microsoft.com/office/drawing/2014/main" id="{5DC45231-E9BC-4550-9375-CA2A02AA2364}"/>
-              </a:ext>
-            </a:extLst>
-          </p:cNvPr>
-          <p:cNvSpPr>
-            <a:spLocks xmlns:a="http://schemas.openxmlformats.org/drawingml/2006/main" noGrp="1"/>
-          </p:cNvSpPr>
-          <p:nvPr/>
-        </p:nvSpPr>
-        <p:spPr>
-          <a:xfrm xmlns:a="http://schemas.openxmlformats.org/drawingml/2006/main">
-            <a:off x="1333500" y="5286375"/>
-            <a:ext cx="10287000" cy="323850"/>
-          </a:xfrm>
-          <a:prstGeom xmlns:a="http://schemas.openxmlformats.org/drawingml/2006/main" prst="rect">
-            <a:avLst/>
-          </a:prstGeom>
-          <a:noFill xmlns:a="http://schemas.openxmlformats.org/drawingml/2006/main"/>
-          <a:ln xmlns:a="http://schemas.openxmlformats.org/drawingml/2006/main" w="0">
-            <a:noFill/>
-          </a:ln>
-        </p:spPr>
-        <p:txBody>
-          <a:bodyPr xmlns:a="http://schemas.openxmlformats.org/drawingml/2006/main" wrap="square" lIns="0" tIns="0" rIns="0" bIns="0" anchor="ctr">
-            <a:noAutofit/>
-          </a:bodyPr>
-          <a:lstStyle xmlns:a="http://schemas.openxmlformats.org/drawingml/2006/main">
-            <a:defPPr algn="l">
-              <a:defRPr sz="1800" b="0">
-                <a:solidFill>
-                  <a:srgbClr val="102B40"/>
-                </a:solidFill>
-                <a:latin typeface="Heiti TC"/>
-                <a:ea typeface="Heiti TC"/>
-                <a:cs typeface="Heiti TC"/>
-              </a:defRPr>
-            </a:defPPr>
-            <a:lvl1pPr algn="l">
-              <a:defRPr sz="1800" b="0">
-                <a:solidFill>
-                  <a:srgbClr val="102B40"/>
-                </a:solidFill>
-                <a:latin typeface="Heiti TC"/>
-                <a:ea typeface="Heiti TC"/>
-                <a:cs typeface="Heiti TC"/>
-              </a:defRPr>
-            </a:lvl1pPr>
-            <a:lvl2pPr algn="l">
-              <a:defRPr sz="1800" b="0">
-                <a:solidFill>
-                  <a:srgbClr val="102B40"/>
-                </a:solidFill>
-                <a:latin typeface="Heiti TC"/>
-                <a:ea typeface="Heiti TC"/>
-                <a:cs typeface="Heiti TC"/>
-              </a:defRPr>
-            </a:lvl2pPr>
-            <a:lvl3pPr algn="l">
-              <a:defRPr sz="1800" b="0">
-                <a:solidFill>
-                  <a:srgbClr val="102B40"/>
-                </a:solidFill>
-                <a:latin typeface="Heiti TC"/>
-                <a:ea typeface="Heiti TC"/>
-                <a:cs typeface="Heiti TC"/>
-              </a:defRPr>
-            </a:lvl3pPr>
-            <a:lvl4pPr algn="l">
-              <a:defRPr sz="1800" b="0">
-                <a:solidFill>
-                  <a:srgbClr val="102B40"/>
-                </a:solidFill>
-                <a:latin typeface="Heiti TC"/>
-                <a:ea typeface="Heiti TC"/>
-                <a:cs typeface="Heiti TC"/>
-              </a:defRPr>
-            </a:lvl4pPr>
-            <a:lvl5pPr algn="l">
-              <a:defRPr sz="1800" b="0">
-                <a:solidFill>
-                  <a:srgbClr val="102B40"/>
-                </a:solidFill>
-                <a:latin typeface="Heiti TC"/>
-                <a:ea typeface="Heiti TC"/>
-                <a:cs typeface="Heiti TC"/>
-              </a:defRPr>
-            </a:lvl5pPr>
-            <a:lvl6pPr algn="l">
-              <a:defRPr sz="1800" b="0">
-                <a:solidFill>
-                  <a:srgbClr val="102B40"/>
-                </a:solidFill>
-                <a:latin typeface="Heiti TC"/>
-                <a:ea typeface="Heiti TC"/>
-                <a:cs typeface="Heiti TC"/>
-              </a:defRPr>
-            </a:lvl6pPr>
-            <a:lvl7pPr algn="l">
-              <a:defRPr sz="1800" b="0">
-                <a:solidFill>
-                  <a:srgbClr val="102B40"/>
-                </a:solidFill>
-                <a:latin typeface="Heiti TC"/>
-                <a:ea typeface="Heiti TC"/>
-                <a:cs typeface="Heiti TC"/>
-              </a:defRPr>
-            </a:lvl7pPr>
-            <a:lvl8pPr algn="l">
-              <a:defRPr sz="1800" b="0">
-                <a:solidFill>
-                  <a:srgbClr val="102B40"/>
-                </a:solidFill>
-                <a:latin typeface="Heiti TC"/>
-                <a:ea typeface="Heiti TC"/>
-                <a:cs typeface="Heiti TC"/>
-              </a:defRPr>
-            </a:lvl8pPr>
-            <a:lvl9pPr algn="l">
-              <a:defRPr sz="1800" b="0">
-                <a:solidFill>
-                  <a:srgbClr val="102B40"/>
-                </a:solidFill>
-                <a:latin typeface="Heiti TC"/>
-                <a:ea typeface="Heiti TC"/>
-                <a:cs typeface="Heiti TC"/>
-              </a:defRPr>
-            </a:lvl9pPr>
-          </a:lstStyle>
-          <a:p xmlns:a="http://schemas.openxmlformats.org/drawingml/2006/main">
-            <a:pPr algn="l">
-              <a:defRPr sz="1800" b="0">
-                <a:solidFill>
-                  <a:srgbClr val="102B40"/>
-                </a:solidFill>
-                <a:latin typeface="Heiti TC"/>
-                <a:ea typeface="Heiti TC"/>
-                <a:cs typeface="Heiti TC"/>
-              </a:defRPr>
-            </a:pPr>
-            <a:r>
-              <a:rPr sz="1800" b="0">
-                <a:solidFill>
-                  <a:srgbClr val="102B40"/>
-                </a:solidFill>
-                <a:latin typeface="Heiti TC"/>
-                <a:ea typeface="Heiti TC"/>
-                <a:cs typeface="Heiti TC"/>
-              </a:rPr>
-              <a:t>保存子块向量与正文、父块 ID、版本，以及品牌、型号等过滤字段</a:t>
-            </a:r>
-          </a:p>
-        </p:txBody>
-      </p:sp>
-      <p:sp>
-        <p:nvSpPr>
-          <p:cNvPr id="23" name="参数改变重新确认，同一申请不重复创建">
-            <a:extLst xmlns:a="http://schemas.openxmlformats.org/drawingml/2006/main">
-              <a:ext uri="{FF2B5EF4-FFF2-40B4-BE49-F238E27FC236}">
-                <a16:creationId xmlns:a16="http://schemas.microsoft.com/office/drawing/2014/main" id="{6EA75AA5-9061-4479-9B60-DC43384B4F16}"/>
-              </a:ext>
-            </a:extLst>
-          </p:cNvPr>
-          <p:cNvSpPr>
-            <a:spLocks xmlns:a="http://schemas.openxmlformats.org/drawingml/2006/main" noGrp="1"/>
-          </p:cNvSpPr>
-          <p:nvPr/>
-        </p:nvSpPr>
-        <p:spPr>
-          <a:xfrm xmlns:a="http://schemas.openxmlformats.org/drawingml/2006/main">
-            <a:off x="6096000" y="4838700"/>
-            <a:ext cx="5476875" cy="400050"/>
-          </a:xfrm>
-          <a:prstGeom xmlns:a="http://schemas.openxmlformats.org/drawingml/2006/main" prst="rect">
-            <a:avLst/>
-          </a:prstGeom>
-          <a:noFill xmlns:a="http://schemas.openxmlformats.org/drawingml/2006/main"/>
-          <a:ln xmlns:a="http://schemas.openxmlformats.org/drawingml/2006/main" w="0">
-            <a:noFill/>
-          </a:ln>
-        </p:spPr>
-        <p:txBody>
-          <a:bodyPr xmlns:a="http://schemas.openxmlformats.org/drawingml/2006/main" wrap="square" lIns="0" tIns="0" rIns="0" bIns="0" anchor="ctr">
-            <a:noAutofit/>
-          </a:bodyPr>
-          <a:lstStyle xmlns:a="http://schemas.openxmlformats.org/drawingml/2006/main">
-            <a:defPPr algn="l">
-              <a:defRPr sz="1725" b="0">
-                <a:solidFill>
-                  <a:srgbClr val="087F8C"/>
-                </a:solidFill>
-                <a:latin typeface="Heiti TC"/>
-                <a:ea typeface="Heiti TC"/>
-                <a:cs typeface="Heiti TC"/>
-              </a:defRPr>
-            </a:defPPr>
-            <a:lvl1pPr algn="l">
-              <a:defRPr sz="1725" b="0">
-                <a:solidFill>
-                  <a:srgbClr val="087F8C"/>
-                </a:solidFill>
-                <a:latin typeface="Heiti TC"/>
-                <a:ea typeface="Heiti TC"/>
-                <a:cs typeface="Heiti TC"/>
-              </a:defRPr>
-            </a:lvl1pPr>
-            <a:lvl2pPr algn="l">
-              <a:defRPr sz="1725" b="0">
-                <a:solidFill>
-                  <a:srgbClr val="087F8C"/>
-                </a:solidFill>
-                <a:latin typeface="Heiti TC"/>
-                <a:ea typeface="Heiti TC"/>
-                <a:cs typeface="Heiti TC"/>
-              </a:defRPr>
-            </a:lvl2pPr>
-            <a:lvl3pPr algn="l">
-              <a:defRPr sz="1725" b="0">
-                <a:solidFill>
-                  <a:srgbClr val="087F8C"/>
-                </a:solidFill>
-                <a:latin typeface="Heiti TC"/>
-                <a:ea typeface="Heiti TC"/>
-                <a:cs typeface="Heiti TC"/>
-              </a:defRPr>
-            </a:lvl3pPr>
-            <a:lvl4pPr algn="l">
-              <a:defRPr sz="1725" b="0">
-                <a:solidFill>
-                  <a:srgbClr val="087F8C"/>
-                </a:solidFill>
-                <a:latin typeface="Heiti TC"/>
-                <a:ea typeface="Heiti TC"/>
-                <a:cs typeface="Heiti TC"/>
-              </a:defRPr>
-            </a:lvl4pPr>
-            <a:lvl5pPr algn="l">
-              <a:defRPr sz="1725" b="0">
-                <a:solidFill>
-                  <a:srgbClr val="087F8C"/>
-                </a:solidFill>
-                <a:latin typeface="Heiti TC"/>
-                <a:ea typeface="Heiti TC"/>
-                <a:cs typeface="Heiti TC"/>
-              </a:defRPr>
-            </a:lvl5pPr>
-            <a:lvl6pPr algn="l">
-              <a:defRPr sz="1725" b="0">
-                <a:solidFill>
-                  <a:srgbClr val="087F8C"/>
-                </a:solidFill>
-                <a:latin typeface="Heiti TC"/>
-                <a:ea typeface="Heiti TC"/>
-                <a:cs typeface="Heiti TC"/>
-              </a:defRPr>
-            </a:lvl6pPr>
-            <a:lvl7pPr algn="l">
-              <a:defRPr sz="1725" b="0">
-                <a:solidFill>
-                  <a:srgbClr val="087F8C"/>
-                </a:solidFill>
-                <a:latin typeface="Heiti TC"/>
-                <a:ea typeface="Heiti TC"/>
-                <a:cs typeface="Heiti TC"/>
-              </a:defRPr>
-            </a:lvl7pPr>
-            <a:lvl8pPr algn="l">
-              <a:defRPr sz="1725" b="0">
-                <a:solidFill>
-                  <a:srgbClr val="087F8C"/>
-                </a:solidFill>
-                <a:latin typeface="Heiti TC"/>
-                <a:ea typeface="Heiti TC"/>
-                <a:cs typeface="Heiti TC"/>
-              </a:defRPr>
-            </a:lvl8pPr>
-            <a:lvl9pPr algn="l">
-              <a:defRPr sz="1725" b="0">
-                <a:solidFill>
-                  <a:srgbClr val="087F8C"/>
-                </a:solidFill>
-                <a:latin typeface="Heiti TC"/>
-                <a:ea typeface="Heiti TC"/>
-                <a:cs typeface="Heiti TC"/>
-              </a:defRPr>
-            </a:lvl9pPr>
-          </a:lstStyle>
-          <a:p xmlns:a="http://schemas.openxmlformats.org/drawingml/2006/main">
-            <a:pPr algn="l">
-              <a:defRPr sz="1725" b="0">
-                <a:solidFill>
-                  <a:srgbClr val="087F8C"/>
-                </a:solidFill>
-                <a:latin typeface="Heiti TC"/>
-                <a:ea typeface="Heiti TC"/>
-                <a:cs typeface="Heiti TC"/>
-              </a:defRPr>
-            </a:pPr>
-            <a:r>
-              <a:rPr sz="1725" b="0">
-                <a:solidFill>
-                  <a:srgbClr val="087F8C"/>
-                </a:solidFill>
-                <a:latin typeface="Heiti TC"/>
-                <a:ea typeface="Heiti TC"/>
-                <a:cs typeface="Heiti TC"/>
-              </a:rPr>
-              <a:t>BGE-M3 生成 Dense + Sparse 向量</a:t>
-            </a:r>
-          </a:p>
-        </p:txBody>
-      </p:sp>
-      <p:cxnSp>
-        <p:nvCxnSpPr>
-          <p:cNvPr id="24" name="">
-            <a:extLst xmlns:a="http://schemas.openxmlformats.org/drawingml/2006/main">
-              <a:ext uri="{FF2B5EF4-FFF2-40B4-BE49-F238E27FC236}">
-                <a16:creationId xmlns:a16="http://schemas.microsoft.com/office/drawing/2014/main" id="{8BF45905-7D91-4B11-903D-D27CB3879753}"/>
-              </a:ext>
-            </a:extLst>
-          </p:cNvPr>
-          <p:cNvCxnSpPr/>
-          <p:nvPr/>
-        </p:nvCxnSpPr>
-        <p:spPr>
-          <a:xfrm xmlns:a="http://schemas.openxmlformats.org/drawingml/2006/main" flipH="0" flipV="0">
-            <a:off x="1333500" y="5772150"/>
-            <a:ext cx="10334625" cy="0"/>
-          </a:xfrm>
-          <a:prstGeom xmlns:a="http://schemas.openxmlformats.org/drawingml/2006/main" prst="straightConnector1">
-            <a:avLst/>
-          </a:prstGeom>
-          <a:ln xmlns:a="http://schemas.openxmlformats.org/drawingml/2006/main" w="15240">
-            <a:solidFill>
-              <a:srgbClr val="B6C8D6"/>
-            </a:solidFill>
-            <a:prstDash val="solid"/>
-            <a:tailEnd type="none" w="med" len="med"/>
-          </a:ln>
-        </p:spPr>
-      </p:cxnSp>
-      <p:sp>
-        <p:nvSpPr>
-          <p:cNvPr id="25" name="知识来自同一份 Markdown 正文，内部保留来源与版本；未找到依据时明确说明无法核实">
-            <a:extLst xmlns:a="http://schemas.openxmlformats.org/drawingml/2006/main">
-              <a:ext uri="{FF2B5EF4-FFF2-40B4-BE49-F238E27FC236}">
-                <a16:creationId xmlns:a16="http://schemas.microsoft.com/office/drawing/2014/main" id="{FEC3C36D-A8DF-487A-8E3C-46F0EE42A27D}"/>
-              </a:ext>
-            </a:extLst>
-          </p:cNvPr>
-          <p:cNvSpPr>
-            <a:spLocks xmlns:a="http://schemas.openxmlformats.org/drawingml/2006/main" noGrp="1"/>
-          </p:cNvSpPr>
-          <p:nvPr/>
-        </p:nvSpPr>
-        <p:spPr>
-          <a:xfrm xmlns:a="http://schemas.openxmlformats.org/drawingml/2006/main">
-            <a:off x="542925" y="6076950"/>
-            <a:ext cx="11096625" cy="304800"/>
-          </a:xfrm>
-          <a:prstGeom xmlns:a="http://schemas.openxmlformats.org/drawingml/2006/main" prst="rect">
-            <a:avLst/>
-          </a:prstGeom>
-          <a:noFill xmlns:a="http://schemas.openxmlformats.org/drawingml/2006/main"/>
-          <a:ln xmlns:a="http://schemas.openxmlformats.org/drawingml/2006/main" w="0">
-            <a:noFill/>
-          </a:ln>
-        </p:spPr>
-        <p:txBody>
-          <a:bodyPr xmlns:a="http://schemas.openxmlformats.org/drawingml/2006/main" wrap="square" lIns="0" tIns="0" rIns="0" bIns="0" anchor="ctr">
-            <a:noAutofit/>
-          </a:bodyPr>
-          <a:lstStyle xmlns:a="http://schemas.openxmlformats.org/drawingml/2006/main">
-            <a:defPPr algn="l">
-              <a:defRPr sz="1650" b="0">
-                <a:solidFill>
-                  <a:srgbClr val="536A79"/>
-                </a:solidFill>
-                <a:latin typeface="Heiti TC"/>
-                <a:ea typeface="Heiti TC"/>
-                <a:cs typeface="Heiti TC"/>
-              </a:defRPr>
-            </a:defPPr>
-            <a:lvl1pPr algn="l">
-              <a:defRPr sz="1650" b="0">
-                <a:solidFill>
-                  <a:srgbClr val="536A79"/>
-                </a:solidFill>
-                <a:latin typeface="Heiti TC"/>
-                <a:ea typeface="Heiti TC"/>
-                <a:cs typeface="Heiti TC"/>
-              </a:defRPr>
-            </a:lvl1pPr>
-            <a:lvl2pPr algn="l">
-              <a:defRPr sz="1650" b="0">
-                <a:solidFill>
-                  <a:srgbClr val="536A79"/>
-                </a:solidFill>
-                <a:latin typeface="Heiti TC"/>
-                <a:ea typeface="Heiti TC"/>
-                <a:cs typeface="Heiti TC"/>
-              </a:defRPr>
-            </a:lvl2pPr>
-            <a:lvl3pPr algn="l">
-              <a:defRPr sz="1650" b="0">
-                <a:solidFill>
-                  <a:srgbClr val="536A79"/>
-                </a:solidFill>
-                <a:latin typeface="Heiti TC"/>
-                <a:ea typeface="Heiti TC"/>
-                <a:cs typeface="Heiti TC"/>
-              </a:defRPr>
-            </a:lvl3pPr>
-            <a:lvl4pPr algn="l">
-              <a:defRPr sz="1650" b="0">
-                <a:solidFill>
-                  <a:srgbClr val="536A79"/>
-                </a:solidFill>
-                <a:latin typeface="Heiti TC"/>
-                <a:ea typeface="Heiti TC"/>
-                <a:cs typeface="Heiti TC"/>
-              </a:defRPr>
-            </a:lvl4pPr>
-            <a:lvl5pPr algn="l">
-              <a:defRPr sz="1650" b="0">
-                <a:solidFill>
-                  <a:srgbClr val="536A79"/>
-                </a:solidFill>
-                <a:latin typeface="Heiti TC"/>
-                <a:ea typeface="Heiti TC"/>
-                <a:cs typeface="Heiti TC"/>
-              </a:defRPr>
-            </a:lvl5pPr>
-            <a:lvl6pPr algn="l">
-              <a:defRPr sz="1650" b="0">
-                <a:solidFill>
-                  <a:srgbClr val="536A79"/>
-                </a:solidFill>
-                <a:latin typeface="Heiti TC"/>
-                <a:ea typeface="Heiti TC"/>
-                <a:cs typeface="Heiti TC"/>
-              </a:defRPr>
-            </a:lvl6pPr>
-            <a:lvl7pPr algn="l">
-              <a:defRPr sz="1650" b="0">
-                <a:solidFill>
-                  <a:srgbClr val="536A79"/>
-                </a:solidFill>
-                <a:latin typeface="Heiti TC"/>
-                <a:ea typeface="Heiti TC"/>
-                <a:cs typeface="Heiti TC"/>
-              </a:defRPr>
-            </a:lvl7pPr>
-            <a:lvl8pPr algn="l">
-              <a:defRPr sz="1650" b="0">
-                <a:solidFill>
-                  <a:srgbClr val="536A79"/>
-                </a:solidFill>
-                <a:latin typeface="Heiti TC"/>
-                <a:ea typeface="Heiti TC"/>
-                <a:cs typeface="Heiti TC"/>
-              </a:defRPr>
-            </a:lvl8pPr>
-            <a:lvl9pPr algn="l">
-              <a:defRPr sz="1650" b="0">
-                <a:solidFill>
-                  <a:srgbClr val="536A79"/>
-                </a:solidFill>
-                <a:latin typeface="Heiti TC"/>
-                <a:ea typeface="Heiti TC"/>
-                <a:cs typeface="Heiti TC"/>
-              </a:defRPr>
-            </a:lvl9pPr>
-          </a:lstStyle>
-          <a:p xmlns:a="http://schemas.openxmlformats.org/drawingml/2006/main">
-            <a:pPr algn="l">
-              <a:defRPr sz="1650" b="0">
-                <a:solidFill>
-                  <a:srgbClr val="536A79"/>
-                </a:solidFill>
-                <a:latin typeface="Heiti TC"/>
-                <a:ea typeface="Heiti TC"/>
-                <a:cs typeface="Heiti TC"/>
-              </a:defRPr>
-            </a:pPr>
-            <a:r>
-              <a:rPr sz="1650" b="0">
-                <a:solidFill>
-                  <a:srgbClr val="536A79"/>
-                </a:solidFill>
-                <a:latin typeface="Heiti TC"/>
-                <a:ea typeface="Heiti TC"/>
-                <a:cs typeface="Heiti TC"/>
-              </a:rPr>
-              <a:t>检索时先命中子块，再按父块 ID 与版本回查 PostgreSQL，补齐上下文</a:t>
-            </a:r>
-          </a:p>
-        </p:txBody>
-      </p:sp>
-    </p:spTree>
-    <p:extLst>
-      <p:ext uri="{BB962C8B-B14F-4D97-AF65-F5344CB8AC3E}">
-        <p14:creationId xmlns:p14="http://schemas.microsoft.com/office/powerpoint/2010/main" val="1593274156"/>
       </p:ext>
     </p:extLst>
   </p:cSld>

</xml_diff>